<commit_message>
adding tasks intro for task 1 and 2
task 1 and 2 outlines with dot points
</commit_message>
<xml_diff>
--- a/ECE2071_Project_F08_PPTslides.pptx
+++ b/ECE2071_Project_F08_PPTslides.pptx
@@ -5,10 +5,10 @@
     <p:sldMasterId id="2147483658" r:id="rId4"/>
   </p:sldMasterIdLst>
   <p:notesMasterIdLst>
-    <p:notesMasterId r:id="rId14"/>
+    <p:notesMasterId r:id="rId18"/>
   </p:notesMasterIdLst>
   <p:handoutMasterIdLst>
-    <p:handoutMasterId r:id="rId15"/>
+    <p:handoutMasterId r:id="rId19"/>
   </p:handoutMasterIdLst>
   <p:sldIdLst>
     <p:sldId id="383" r:id="rId5"/>
@@ -17,9 +17,13 @@
     <p:sldId id="397" r:id="rId8"/>
     <p:sldId id="408" r:id="rId9"/>
     <p:sldId id="409" r:id="rId10"/>
-    <p:sldId id="410" r:id="rId11"/>
-    <p:sldId id="411" r:id="rId12"/>
-    <p:sldId id="398" r:id="rId13"/>
+    <p:sldId id="413" r:id="rId11"/>
+    <p:sldId id="414" r:id="rId12"/>
+    <p:sldId id="410" r:id="rId13"/>
+    <p:sldId id="415" r:id="rId14"/>
+    <p:sldId id="411" r:id="rId15"/>
+    <p:sldId id="416" r:id="rId16"/>
+    <p:sldId id="398" r:id="rId17"/>
   </p:sldIdLst>
   <p:sldSz cx="12192000" cy="6858000"/>
   <p:notesSz cx="6858000" cy="9144000"/>
@@ -763,6 +767,13 @@
           </p:nvPr>
         </p:nvSpPr>
         <p:spPr/>
+        <p:txBody>
+          <a:bodyPr/>
+          <a:lstStyle/>
+          <a:p>
+            <a:endParaRPr lang="zh-CN" altLang="en-US"/>
+          </a:p>
+        </p:txBody>
       </p:sp>
       <p:sp>
         <p:nvSpPr>
@@ -820,6 +831,482 @@
     <p:extLst>
       <p:ext uri="{BB962C8B-B14F-4D97-AF65-F5344CB8AC3E}">
         <p14:creationId xmlns:p14="http://schemas.microsoft.com/office/powerpoint/2010/main" val="3113416817"/>
+      </p:ext>
+    </p:extLst>
+  </p:cSld>
+  <p:clrMapOvr>
+    <a:masterClrMapping/>
+  </p:clrMapOvr>
+</p:notes>
+</file>
+
+<file path=ppt/notesSlides/notesSlide10.xml><?xml version="1.0" encoding="utf-8"?>
+<p:notes xmlns:a="http://schemas.openxmlformats.org/drawingml/2006/main" xmlns:r="http://schemas.openxmlformats.org/officeDocument/2006/relationships" xmlns:p="http://schemas.openxmlformats.org/presentationml/2006/main">
+  <p:cSld>
+    <p:spTree>
+      <p:nvGrpSpPr>
+        <p:cNvPr id="1" name="">
+          <a:extLst>
+            <a:ext uri="{FF2B5EF4-FFF2-40B4-BE49-F238E27FC236}">
+              <a16:creationId xmlns:a16="http://schemas.microsoft.com/office/drawing/2014/main" id="{3B0B281C-CEBA-BD9E-5E95-680754F90DD2}"/>
+            </a:ext>
+          </a:extLst>
+        </p:cNvPr>
+        <p:cNvGrpSpPr/>
+        <p:nvPr/>
+      </p:nvGrpSpPr>
+      <p:grpSpPr>
+        <a:xfrm>
+          <a:off x="0" y="0"/>
+          <a:ext cx="0" cy="0"/>
+          <a:chOff x="0" y="0"/>
+          <a:chExt cx="0" cy="0"/>
+        </a:xfrm>
+      </p:grpSpPr>
+      <p:sp>
+        <p:nvSpPr>
+          <p:cNvPr id="2" name="幻灯片图像占位符 1">
+            <a:extLst>
+              <a:ext uri="{FF2B5EF4-FFF2-40B4-BE49-F238E27FC236}">
+                <a16:creationId xmlns:a16="http://schemas.microsoft.com/office/drawing/2014/main" id="{85997BCD-EDC2-4D69-1DF2-2CFD508DD44E}"/>
+              </a:ext>
+            </a:extLst>
+          </p:cNvPr>
+          <p:cNvSpPr>
+            <a:spLocks noGrp="1" noRot="1" noChangeAspect="1"/>
+          </p:cNvSpPr>
+          <p:nvPr>
+            <p:ph type="sldImg"/>
+          </p:nvPr>
+        </p:nvSpPr>
+        <p:spPr/>
+        <p:txBody>
+          <a:bodyPr/>
+          <a:lstStyle/>
+          <a:p>
+            <a:endParaRPr lang="zh-CN" altLang="en-US"/>
+          </a:p>
+        </p:txBody>
+      </p:sp>
+      <p:sp>
+        <p:nvSpPr>
+          <p:cNvPr id="3" name="备注占位符 2">
+            <a:extLst>
+              <a:ext uri="{FF2B5EF4-FFF2-40B4-BE49-F238E27FC236}">
+                <a16:creationId xmlns:a16="http://schemas.microsoft.com/office/drawing/2014/main" id="{85728A51-F84E-AB48-6966-45691DBD5D95}"/>
+              </a:ext>
+            </a:extLst>
+          </p:cNvPr>
+          <p:cNvSpPr>
+            <a:spLocks noGrp="1"/>
+          </p:cNvSpPr>
+          <p:nvPr>
+            <p:ph type="body" idx="1"/>
+          </p:nvPr>
+        </p:nvSpPr>
+        <p:spPr/>
+        <p:txBody>
+          <a:bodyPr rtlCol="0"/>
+          <a:lstStyle>
+            <a:defPPr>
+              <a:defRPr lang="zh-CN"/>
+            </a:defPPr>
+          </a:lstStyle>
+          <a:p>
+            <a:pPr rtl="0"/>
+            <a:endParaRPr lang="zh-CN" dirty="0"/>
+          </a:p>
+        </p:txBody>
+      </p:sp>
+      <p:sp>
+        <p:nvSpPr>
+          <p:cNvPr id="4" name="幻灯片编号占位符 3">
+            <a:extLst>
+              <a:ext uri="{FF2B5EF4-FFF2-40B4-BE49-F238E27FC236}">
+                <a16:creationId xmlns:a16="http://schemas.microsoft.com/office/drawing/2014/main" id="{2FE60AD4-5AF2-C1EE-B495-20F1822502D6}"/>
+              </a:ext>
+            </a:extLst>
+          </p:cNvPr>
+          <p:cNvSpPr>
+            <a:spLocks noGrp="1"/>
+          </p:cNvSpPr>
+          <p:nvPr>
+            <p:ph type="sldNum" sz="quarter" idx="5"/>
+          </p:nvPr>
+        </p:nvSpPr>
+        <p:spPr/>
+        <p:txBody>
+          <a:bodyPr rtlCol="0"/>
+          <a:lstStyle>
+            <a:defPPr>
+              <a:defRPr lang="zh-CN"/>
+            </a:defPPr>
+          </a:lstStyle>
+          <a:p>
+            <a:pPr rtl="0"/>
+            <a:fld id="{A89C7E07-3C67-C64C-8DA0-0404F6303970}" type="slidenum">
+              <a:rPr lang="en-US" altLang="zh-CN" smtClean="0"/>
+              <a:t>10</a:t>
+            </a:fld>
+            <a:endParaRPr lang="zh-CN" dirty="0"/>
+          </a:p>
+        </p:txBody>
+      </p:sp>
+    </p:spTree>
+    <p:extLst>
+      <p:ext uri="{BB962C8B-B14F-4D97-AF65-F5344CB8AC3E}">
+        <p14:creationId xmlns:p14="http://schemas.microsoft.com/office/powerpoint/2010/main" val="605045557"/>
+      </p:ext>
+    </p:extLst>
+  </p:cSld>
+  <p:clrMapOvr>
+    <a:masterClrMapping/>
+  </p:clrMapOvr>
+</p:notes>
+</file>
+
+<file path=ppt/notesSlides/notesSlide11.xml><?xml version="1.0" encoding="utf-8"?>
+<p:notes xmlns:a="http://schemas.openxmlformats.org/drawingml/2006/main" xmlns:r="http://schemas.openxmlformats.org/officeDocument/2006/relationships" xmlns:p="http://schemas.openxmlformats.org/presentationml/2006/main">
+  <p:cSld>
+    <p:spTree>
+      <p:nvGrpSpPr>
+        <p:cNvPr id="1" name="">
+          <a:extLst>
+            <a:ext uri="{FF2B5EF4-FFF2-40B4-BE49-F238E27FC236}">
+              <a16:creationId xmlns:a16="http://schemas.microsoft.com/office/drawing/2014/main" id="{1B824428-F043-0080-79D9-B80C66689270}"/>
+            </a:ext>
+          </a:extLst>
+        </p:cNvPr>
+        <p:cNvGrpSpPr/>
+        <p:nvPr/>
+      </p:nvGrpSpPr>
+      <p:grpSpPr>
+        <a:xfrm>
+          <a:off x="0" y="0"/>
+          <a:ext cx="0" cy="0"/>
+          <a:chOff x="0" y="0"/>
+          <a:chExt cx="0" cy="0"/>
+        </a:xfrm>
+      </p:grpSpPr>
+      <p:sp>
+        <p:nvSpPr>
+          <p:cNvPr id="2" name="幻灯片图像占位符 1">
+            <a:extLst>
+              <a:ext uri="{FF2B5EF4-FFF2-40B4-BE49-F238E27FC236}">
+                <a16:creationId xmlns:a16="http://schemas.microsoft.com/office/drawing/2014/main" id="{4A6856CE-5354-3689-4F5A-E8C1651018AC}"/>
+              </a:ext>
+            </a:extLst>
+          </p:cNvPr>
+          <p:cNvSpPr>
+            <a:spLocks noGrp="1" noRot="1" noChangeAspect="1"/>
+          </p:cNvSpPr>
+          <p:nvPr>
+            <p:ph type="sldImg"/>
+          </p:nvPr>
+        </p:nvSpPr>
+        <p:spPr/>
+        <p:txBody>
+          <a:bodyPr/>
+          <a:lstStyle/>
+          <a:p>
+            <a:endParaRPr lang="zh-CN" altLang="en-US"/>
+          </a:p>
+        </p:txBody>
+      </p:sp>
+      <p:sp>
+        <p:nvSpPr>
+          <p:cNvPr id="3" name="备注占位符 2">
+            <a:extLst>
+              <a:ext uri="{FF2B5EF4-FFF2-40B4-BE49-F238E27FC236}">
+                <a16:creationId xmlns:a16="http://schemas.microsoft.com/office/drawing/2014/main" id="{D09A3267-8466-7F6E-497D-2920717D9FD3}"/>
+              </a:ext>
+            </a:extLst>
+          </p:cNvPr>
+          <p:cNvSpPr>
+            <a:spLocks noGrp="1"/>
+          </p:cNvSpPr>
+          <p:nvPr>
+            <p:ph type="body" idx="1"/>
+          </p:nvPr>
+        </p:nvSpPr>
+        <p:spPr/>
+        <p:txBody>
+          <a:bodyPr rtlCol="0"/>
+          <a:lstStyle>
+            <a:defPPr>
+              <a:defRPr lang="zh-CN"/>
+            </a:defPPr>
+          </a:lstStyle>
+          <a:p>
+            <a:pPr rtl="0"/>
+            <a:endParaRPr lang="zh-CN" dirty="0"/>
+          </a:p>
+        </p:txBody>
+      </p:sp>
+      <p:sp>
+        <p:nvSpPr>
+          <p:cNvPr id="4" name="幻灯片编号占位符 3">
+            <a:extLst>
+              <a:ext uri="{FF2B5EF4-FFF2-40B4-BE49-F238E27FC236}">
+                <a16:creationId xmlns:a16="http://schemas.microsoft.com/office/drawing/2014/main" id="{48A274E0-A950-9BFC-4BC2-231DB15F2DF7}"/>
+              </a:ext>
+            </a:extLst>
+          </p:cNvPr>
+          <p:cNvSpPr>
+            <a:spLocks noGrp="1"/>
+          </p:cNvSpPr>
+          <p:nvPr>
+            <p:ph type="sldNum" sz="quarter" idx="5"/>
+          </p:nvPr>
+        </p:nvSpPr>
+        <p:spPr/>
+        <p:txBody>
+          <a:bodyPr rtlCol="0"/>
+          <a:lstStyle>
+            <a:defPPr>
+              <a:defRPr lang="zh-CN"/>
+            </a:defPPr>
+          </a:lstStyle>
+          <a:p>
+            <a:pPr rtl="0"/>
+            <a:fld id="{A89C7E07-3C67-C64C-8DA0-0404F6303970}" type="slidenum">
+              <a:rPr lang="en-US" altLang="zh-CN" smtClean="0"/>
+              <a:t>11</a:t>
+            </a:fld>
+            <a:endParaRPr lang="zh-CN" dirty="0"/>
+          </a:p>
+        </p:txBody>
+      </p:sp>
+    </p:spTree>
+    <p:extLst>
+      <p:ext uri="{BB962C8B-B14F-4D97-AF65-F5344CB8AC3E}">
+        <p14:creationId xmlns:p14="http://schemas.microsoft.com/office/powerpoint/2010/main" val="1866824279"/>
+      </p:ext>
+    </p:extLst>
+  </p:cSld>
+  <p:clrMapOvr>
+    <a:masterClrMapping/>
+  </p:clrMapOvr>
+</p:notes>
+</file>
+
+<file path=ppt/notesSlides/notesSlide12.xml><?xml version="1.0" encoding="utf-8"?>
+<p:notes xmlns:a="http://schemas.openxmlformats.org/drawingml/2006/main" xmlns:r="http://schemas.openxmlformats.org/officeDocument/2006/relationships" xmlns:p="http://schemas.openxmlformats.org/presentationml/2006/main">
+  <p:cSld>
+    <p:spTree>
+      <p:nvGrpSpPr>
+        <p:cNvPr id="1" name="">
+          <a:extLst>
+            <a:ext uri="{FF2B5EF4-FFF2-40B4-BE49-F238E27FC236}">
+              <a16:creationId xmlns:a16="http://schemas.microsoft.com/office/drawing/2014/main" id="{86009BAB-6013-CED1-D3DD-51E617D8DA2A}"/>
+            </a:ext>
+          </a:extLst>
+        </p:cNvPr>
+        <p:cNvGrpSpPr/>
+        <p:nvPr/>
+      </p:nvGrpSpPr>
+      <p:grpSpPr>
+        <a:xfrm>
+          <a:off x="0" y="0"/>
+          <a:ext cx="0" cy="0"/>
+          <a:chOff x="0" y="0"/>
+          <a:chExt cx="0" cy="0"/>
+        </a:xfrm>
+      </p:grpSpPr>
+      <p:sp>
+        <p:nvSpPr>
+          <p:cNvPr id="2" name="幻灯片图像占位符 1">
+            <a:extLst>
+              <a:ext uri="{FF2B5EF4-FFF2-40B4-BE49-F238E27FC236}">
+                <a16:creationId xmlns:a16="http://schemas.microsoft.com/office/drawing/2014/main" id="{03B50E73-4763-9BAC-C7F3-DDF8435AE942}"/>
+              </a:ext>
+            </a:extLst>
+          </p:cNvPr>
+          <p:cNvSpPr>
+            <a:spLocks noGrp="1" noRot="1" noChangeAspect="1"/>
+          </p:cNvSpPr>
+          <p:nvPr>
+            <p:ph type="sldImg"/>
+          </p:nvPr>
+        </p:nvSpPr>
+        <p:spPr/>
+        <p:txBody>
+          <a:bodyPr/>
+          <a:lstStyle/>
+          <a:p>
+            <a:endParaRPr lang="zh-CN" altLang="en-US"/>
+          </a:p>
+        </p:txBody>
+      </p:sp>
+      <p:sp>
+        <p:nvSpPr>
+          <p:cNvPr id="3" name="备注占位符 2">
+            <a:extLst>
+              <a:ext uri="{FF2B5EF4-FFF2-40B4-BE49-F238E27FC236}">
+                <a16:creationId xmlns:a16="http://schemas.microsoft.com/office/drawing/2014/main" id="{7D74C990-B1FE-8672-BD93-C8214681B2FE}"/>
+              </a:ext>
+            </a:extLst>
+          </p:cNvPr>
+          <p:cNvSpPr>
+            <a:spLocks noGrp="1"/>
+          </p:cNvSpPr>
+          <p:nvPr>
+            <p:ph type="body" idx="1"/>
+          </p:nvPr>
+        </p:nvSpPr>
+        <p:spPr/>
+        <p:txBody>
+          <a:bodyPr rtlCol="0"/>
+          <a:lstStyle>
+            <a:defPPr>
+              <a:defRPr lang="zh-CN"/>
+            </a:defPPr>
+          </a:lstStyle>
+          <a:p>
+            <a:pPr rtl="0"/>
+            <a:endParaRPr lang="zh-CN" dirty="0"/>
+          </a:p>
+        </p:txBody>
+      </p:sp>
+      <p:sp>
+        <p:nvSpPr>
+          <p:cNvPr id="4" name="幻灯片编号占位符 3">
+            <a:extLst>
+              <a:ext uri="{FF2B5EF4-FFF2-40B4-BE49-F238E27FC236}">
+                <a16:creationId xmlns:a16="http://schemas.microsoft.com/office/drawing/2014/main" id="{00D8A791-56EF-67CB-0039-6E40CADB9548}"/>
+              </a:ext>
+            </a:extLst>
+          </p:cNvPr>
+          <p:cNvSpPr>
+            <a:spLocks noGrp="1"/>
+          </p:cNvSpPr>
+          <p:nvPr>
+            <p:ph type="sldNum" sz="quarter" idx="5"/>
+          </p:nvPr>
+        </p:nvSpPr>
+        <p:spPr/>
+        <p:txBody>
+          <a:bodyPr rtlCol="0"/>
+          <a:lstStyle>
+            <a:defPPr>
+              <a:defRPr lang="zh-CN"/>
+            </a:defPPr>
+          </a:lstStyle>
+          <a:p>
+            <a:pPr rtl="0"/>
+            <a:fld id="{A89C7E07-3C67-C64C-8DA0-0404F6303970}" type="slidenum">
+              <a:rPr lang="en-US" altLang="zh-CN" smtClean="0"/>
+              <a:t>12</a:t>
+            </a:fld>
+            <a:endParaRPr lang="zh-CN" dirty="0"/>
+          </a:p>
+        </p:txBody>
+      </p:sp>
+    </p:spTree>
+    <p:extLst>
+      <p:ext uri="{BB962C8B-B14F-4D97-AF65-F5344CB8AC3E}">
+        <p14:creationId xmlns:p14="http://schemas.microsoft.com/office/powerpoint/2010/main" val="1526246326"/>
+      </p:ext>
+    </p:extLst>
+  </p:cSld>
+  <p:clrMapOvr>
+    <a:masterClrMapping/>
+  </p:clrMapOvr>
+</p:notes>
+</file>
+
+<file path=ppt/notesSlides/notesSlide13.xml><?xml version="1.0" encoding="utf-8"?>
+<p:notes xmlns:a="http://schemas.openxmlformats.org/drawingml/2006/main" xmlns:r="http://schemas.openxmlformats.org/officeDocument/2006/relationships" xmlns:p="http://schemas.openxmlformats.org/presentationml/2006/main">
+  <p:cSld>
+    <p:spTree>
+      <p:nvGrpSpPr>
+        <p:cNvPr id="1" name=""/>
+        <p:cNvGrpSpPr/>
+        <p:nvPr/>
+      </p:nvGrpSpPr>
+      <p:grpSpPr>
+        <a:xfrm>
+          <a:off x="0" y="0"/>
+          <a:ext cx="0" cy="0"/>
+          <a:chOff x="0" y="0"/>
+          <a:chExt cx="0" cy="0"/>
+        </a:xfrm>
+      </p:grpSpPr>
+      <p:sp>
+        <p:nvSpPr>
+          <p:cNvPr id="2" name="幻灯片图像占位符 1"/>
+          <p:cNvSpPr>
+            <a:spLocks noGrp="1" noRot="1" noChangeAspect="1"/>
+          </p:cNvSpPr>
+          <p:nvPr>
+            <p:ph type="sldImg"/>
+          </p:nvPr>
+        </p:nvSpPr>
+        <p:spPr/>
+        <p:txBody>
+          <a:bodyPr/>
+          <a:lstStyle/>
+          <a:p>
+            <a:endParaRPr lang="zh-CN" altLang="en-US"/>
+          </a:p>
+        </p:txBody>
+      </p:sp>
+      <p:sp>
+        <p:nvSpPr>
+          <p:cNvPr id="3" name="备注占位符 2"/>
+          <p:cNvSpPr>
+            <a:spLocks noGrp="1"/>
+          </p:cNvSpPr>
+          <p:nvPr>
+            <p:ph type="body" idx="1"/>
+          </p:nvPr>
+        </p:nvSpPr>
+        <p:spPr/>
+        <p:txBody>
+          <a:bodyPr rtlCol="0"/>
+          <a:lstStyle>
+            <a:defPPr>
+              <a:defRPr lang="zh-CN"/>
+            </a:defPPr>
+          </a:lstStyle>
+          <a:p>
+            <a:pPr rtl="0"/>
+            <a:endParaRPr lang="zh-CN" dirty="0"/>
+          </a:p>
+        </p:txBody>
+      </p:sp>
+      <p:sp>
+        <p:nvSpPr>
+          <p:cNvPr id="4" name="灯片编号占位符 3"/>
+          <p:cNvSpPr>
+            <a:spLocks noGrp="1"/>
+          </p:cNvSpPr>
+          <p:nvPr>
+            <p:ph type="sldNum" sz="quarter" idx="5"/>
+          </p:nvPr>
+        </p:nvSpPr>
+        <p:spPr/>
+        <p:txBody>
+          <a:bodyPr rtlCol="0"/>
+          <a:lstStyle>
+            <a:defPPr>
+              <a:defRPr lang="zh-CN"/>
+            </a:defPPr>
+          </a:lstStyle>
+          <a:p>
+            <a:pPr rtl="0"/>
+            <a:fld id="{A89C7E07-3C67-C64C-8DA0-0404F6303970}" type="slidenum">
+              <a:rPr lang="en-US" altLang="zh-CN" smtClean="0"/>
+              <a:t>13</a:t>
+            </a:fld>
+            <a:endParaRPr lang="zh-CN" dirty="0"/>
+          </a:p>
+        </p:txBody>
+      </p:sp>
+    </p:spTree>
+    <p:extLst>
+      <p:ext uri="{BB962C8B-B14F-4D97-AF65-F5344CB8AC3E}">
+        <p14:creationId xmlns:p14="http://schemas.microsoft.com/office/powerpoint/2010/main" val="1765923172"/>
       </p:ext>
     </p:extLst>
   </p:cSld>
@@ -869,6 +1356,13 @@
           </p:nvPr>
         </p:nvSpPr>
         <p:spPr/>
+        <p:txBody>
+          <a:bodyPr/>
+          <a:lstStyle/>
+          <a:p>
+            <a:endParaRPr lang="zh-CN" altLang="en-US"/>
+          </a:p>
+        </p:txBody>
       </p:sp>
       <p:sp>
         <p:nvSpPr>
@@ -975,6 +1469,13 @@
           </p:nvPr>
         </p:nvSpPr>
         <p:spPr/>
+        <p:txBody>
+          <a:bodyPr/>
+          <a:lstStyle/>
+          <a:p>
+            <a:endParaRPr lang="zh-CN" altLang="en-US"/>
+          </a:p>
+        </p:txBody>
       </p:sp>
       <p:sp>
         <p:nvSpPr>
@@ -1081,6 +1582,13 @@
           </p:nvPr>
         </p:nvSpPr>
         <p:spPr/>
+        <p:txBody>
+          <a:bodyPr/>
+          <a:lstStyle/>
+          <a:p>
+            <a:endParaRPr lang="zh-CN" altLang="en-US"/>
+          </a:p>
+        </p:txBody>
       </p:sp>
       <p:sp>
         <p:nvSpPr>
@@ -1187,6 +1695,13 @@
           </p:nvPr>
         </p:nvSpPr>
         <p:spPr/>
+        <p:txBody>
+          <a:bodyPr/>
+          <a:lstStyle/>
+          <a:p>
+            <a:endParaRPr lang="zh-CN" altLang="en-US"/>
+          </a:p>
+        </p:txBody>
       </p:sp>
       <p:sp>
         <p:nvSpPr>
@@ -1293,6 +1808,13 @@
           </p:nvPr>
         </p:nvSpPr>
         <p:spPr/>
+        <p:txBody>
+          <a:bodyPr/>
+          <a:lstStyle/>
+          <a:p>
+            <a:endParaRPr lang="zh-CN" altLang="en-US"/>
+          </a:p>
+        </p:txBody>
       </p:sp>
       <p:sp>
         <p:nvSpPr>
@@ -1372,6 +1894,256 @@
 </file>
 
 <file path=ppt/notesSlides/notesSlide7.xml><?xml version="1.0" encoding="utf-8"?>
+<p:notes xmlns:a="http://schemas.openxmlformats.org/drawingml/2006/main" xmlns:r="http://schemas.openxmlformats.org/officeDocument/2006/relationships" xmlns:p="http://schemas.openxmlformats.org/presentationml/2006/main">
+  <p:cSld>
+    <p:spTree>
+      <p:nvGrpSpPr>
+        <p:cNvPr id="1" name="">
+          <a:extLst>
+            <a:ext uri="{FF2B5EF4-FFF2-40B4-BE49-F238E27FC236}">
+              <a16:creationId xmlns:a16="http://schemas.microsoft.com/office/drawing/2014/main" id="{B7A4A2F9-685C-01CD-A8D8-A3E681BA2E5B}"/>
+            </a:ext>
+          </a:extLst>
+        </p:cNvPr>
+        <p:cNvGrpSpPr/>
+        <p:nvPr/>
+      </p:nvGrpSpPr>
+      <p:grpSpPr>
+        <a:xfrm>
+          <a:off x="0" y="0"/>
+          <a:ext cx="0" cy="0"/>
+          <a:chOff x="0" y="0"/>
+          <a:chExt cx="0" cy="0"/>
+        </a:xfrm>
+      </p:grpSpPr>
+      <p:sp>
+        <p:nvSpPr>
+          <p:cNvPr id="2" name="幻灯片图像占位符 1">
+            <a:extLst>
+              <a:ext uri="{FF2B5EF4-FFF2-40B4-BE49-F238E27FC236}">
+                <a16:creationId xmlns:a16="http://schemas.microsoft.com/office/drawing/2014/main" id="{385ED719-5B51-1D3B-0940-E0B5987D4D29}"/>
+              </a:ext>
+            </a:extLst>
+          </p:cNvPr>
+          <p:cNvSpPr>
+            <a:spLocks noGrp="1" noRot="1" noChangeAspect="1"/>
+          </p:cNvSpPr>
+          <p:nvPr>
+            <p:ph type="sldImg"/>
+          </p:nvPr>
+        </p:nvSpPr>
+        <p:spPr/>
+        <p:txBody>
+          <a:bodyPr/>
+          <a:lstStyle/>
+          <a:p>
+            <a:endParaRPr lang="zh-CN" altLang="en-US"/>
+          </a:p>
+        </p:txBody>
+      </p:sp>
+      <p:sp>
+        <p:nvSpPr>
+          <p:cNvPr id="3" name="备注占位符 2">
+            <a:extLst>
+              <a:ext uri="{FF2B5EF4-FFF2-40B4-BE49-F238E27FC236}">
+                <a16:creationId xmlns:a16="http://schemas.microsoft.com/office/drawing/2014/main" id="{074822E2-3C1C-9D5B-3D6D-D8ABBD72E80F}"/>
+              </a:ext>
+            </a:extLst>
+          </p:cNvPr>
+          <p:cNvSpPr>
+            <a:spLocks noGrp="1"/>
+          </p:cNvSpPr>
+          <p:nvPr>
+            <p:ph type="body" idx="1"/>
+          </p:nvPr>
+        </p:nvSpPr>
+        <p:spPr/>
+        <p:txBody>
+          <a:bodyPr rtlCol="0"/>
+          <a:lstStyle>
+            <a:defPPr>
+              <a:defRPr lang="zh-CN"/>
+            </a:defPPr>
+          </a:lstStyle>
+          <a:p>
+            <a:pPr rtl="0"/>
+            <a:endParaRPr lang="zh-CN" dirty="0"/>
+          </a:p>
+        </p:txBody>
+      </p:sp>
+      <p:sp>
+        <p:nvSpPr>
+          <p:cNvPr id="4" name="幻灯片编号占位符 3">
+            <a:extLst>
+              <a:ext uri="{FF2B5EF4-FFF2-40B4-BE49-F238E27FC236}">
+                <a16:creationId xmlns:a16="http://schemas.microsoft.com/office/drawing/2014/main" id="{1FD03FE6-0F4F-5777-3735-C2AAE0761ADB}"/>
+              </a:ext>
+            </a:extLst>
+          </p:cNvPr>
+          <p:cNvSpPr>
+            <a:spLocks noGrp="1"/>
+          </p:cNvSpPr>
+          <p:nvPr>
+            <p:ph type="sldNum" sz="quarter" idx="5"/>
+          </p:nvPr>
+        </p:nvSpPr>
+        <p:spPr/>
+        <p:txBody>
+          <a:bodyPr rtlCol="0"/>
+          <a:lstStyle>
+            <a:defPPr>
+              <a:defRPr lang="zh-CN"/>
+            </a:defPPr>
+          </a:lstStyle>
+          <a:p>
+            <a:pPr rtl="0"/>
+            <a:fld id="{A89C7E07-3C67-C64C-8DA0-0404F6303970}" type="slidenum">
+              <a:rPr lang="en-US" altLang="zh-CN" smtClean="0"/>
+              <a:t>7</a:t>
+            </a:fld>
+            <a:endParaRPr lang="zh-CN" dirty="0"/>
+          </a:p>
+        </p:txBody>
+      </p:sp>
+    </p:spTree>
+    <p:extLst>
+      <p:ext uri="{BB962C8B-B14F-4D97-AF65-F5344CB8AC3E}">
+        <p14:creationId xmlns:p14="http://schemas.microsoft.com/office/powerpoint/2010/main" val="379758515"/>
+      </p:ext>
+    </p:extLst>
+  </p:cSld>
+  <p:clrMapOvr>
+    <a:masterClrMapping/>
+  </p:clrMapOvr>
+</p:notes>
+</file>
+
+<file path=ppt/notesSlides/notesSlide8.xml><?xml version="1.0" encoding="utf-8"?>
+<p:notes xmlns:a="http://schemas.openxmlformats.org/drawingml/2006/main" xmlns:r="http://schemas.openxmlformats.org/officeDocument/2006/relationships" xmlns:p="http://schemas.openxmlformats.org/presentationml/2006/main">
+  <p:cSld>
+    <p:spTree>
+      <p:nvGrpSpPr>
+        <p:cNvPr id="1" name="">
+          <a:extLst>
+            <a:ext uri="{FF2B5EF4-FFF2-40B4-BE49-F238E27FC236}">
+              <a16:creationId xmlns:a16="http://schemas.microsoft.com/office/drawing/2014/main" id="{21829E8F-0629-8A27-BCD7-5DBF64BC1849}"/>
+            </a:ext>
+          </a:extLst>
+        </p:cNvPr>
+        <p:cNvGrpSpPr/>
+        <p:nvPr/>
+      </p:nvGrpSpPr>
+      <p:grpSpPr>
+        <a:xfrm>
+          <a:off x="0" y="0"/>
+          <a:ext cx="0" cy="0"/>
+          <a:chOff x="0" y="0"/>
+          <a:chExt cx="0" cy="0"/>
+        </a:xfrm>
+      </p:grpSpPr>
+      <p:sp>
+        <p:nvSpPr>
+          <p:cNvPr id="2" name="幻灯片图像占位符 1">
+            <a:extLst>
+              <a:ext uri="{FF2B5EF4-FFF2-40B4-BE49-F238E27FC236}">
+                <a16:creationId xmlns:a16="http://schemas.microsoft.com/office/drawing/2014/main" id="{C9207D06-4132-84B9-9631-0F2F3FFFD3EF}"/>
+              </a:ext>
+            </a:extLst>
+          </p:cNvPr>
+          <p:cNvSpPr>
+            <a:spLocks noGrp="1" noRot="1" noChangeAspect="1"/>
+          </p:cNvSpPr>
+          <p:nvPr>
+            <p:ph type="sldImg"/>
+          </p:nvPr>
+        </p:nvSpPr>
+        <p:spPr/>
+        <p:txBody>
+          <a:bodyPr/>
+          <a:lstStyle/>
+          <a:p>
+            <a:endParaRPr lang="zh-CN" altLang="en-US"/>
+          </a:p>
+        </p:txBody>
+      </p:sp>
+      <p:sp>
+        <p:nvSpPr>
+          <p:cNvPr id="3" name="备注占位符 2">
+            <a:extLst>
+              <a:ext uri="{FF2B5EF4-FFF2-40B4-BE49-F238E27FC236}">
+                <a16:creationId xmlns:a16="http://schemas.microsoft.com/office/drawing/2014/main" id="{5123D664-DCD8-BA76-1356-F793AA7023F2}"/>
+              </a:ext>
+            </a:extLst>
+          </p:cNvPr>
+          <p:cNvSpPr>
+            <a:spLocks noGrp="1"/>
+          </p:cNvSpPr>
+          <p:nvPr>
+            <p:ph type="body" idx="1"/>
+          </p:nvPr>
+        </p:nvSpPr>
+        <p:spPr/>
+        <p:txBody>
+          <a:bodyPr rtlCol="0"/>
+          <a:lstStyle>
+            <a:defPPr>
+              <a:defRPr lang="zh-CN"/>
+            </a:defPPr>
+          </a:lstStyle>
+          <a:p>
+            <a:pPr rtl="0"/>
+            <a:endParaRPr lang="zh-CN" dirty="0"/>
+          </a:p>
+        </p:txBody>
+      </p:sp>
+      <p:sp>
+        <p:nvSpPr>
+          <p:cNvPr id="4" name="幻灯片编号占位符 3">
+            <a:extLst>
+              <a:ext uri="{FF2B5EF4-FFF2-40B4-BE49-F238E27FC236}">
+                <a16:creationId xmlns:a16="http://schemas.microsoft.com/office/drawing/2014/main" id="{FE89D3F1-7E90-1673-2965-02F4BC59DBFC}"/>
+              </a:ext>
+            </a:extLst>
+          </p:cNvPr>
+          <p:cNvSpPr>
+            <a:spLocks noGrp="1"/>
+          </p:cNvSpPr>
+          <p:nvPr>
+            <p:ph type="sldNum" sz="quarter" idx="5"/>
+          </p:nvPr>
+        </p:nvSpPr>
+        <p:spPr/>
+        <p:txBody>
+          <a:bodyPr rtlCol="0"/>
+          <a:lstStyle>
+            <a:defPPr>
+              <a:defRPr lang="zh-CN"/>
+            </a:defPPr>
+          </a:lstStyle>
+          <a:p>
+            <a:pPr rtl="0"/>
+            <a:fld id="{A89C7E07-3C67-C64C-8DA0-0404F6303970}" type="slidenum">
+              <a:rPr lang="en-US" altLang="zh-CN" smtClean="0"/>
+              <a:t>8</a:t>
+            </a:fld>
+            <a:endParaRPr lang="zh-CN" dirty="0"/>
+          </a:p>
+        </p:txBody>
+      </p:sp>
+    </p:spTree>
+    <p:extLst>
+      <p:ext uri="{BB962C8B-B14F-4D97-AF65-F5344CB8AC3E}">
+        <p14:creationId xmlns:p14="http://schemas.microsoft.com/office/powerpoint/2010/main" val="3731442705"/>
+      </p:ext>
+    </p:extLst>
+  </p:cSld>
+  <p:clrMapOvr>
+    <a:masterClrMapping/>
+  </p:clrMapOvr>
+</p:notes>
+</file>
+
+<file path=ppt/notesSlides/notesSlide9.xml><?xml version="1.0" encoding="utf-8"?>
 <p:notes xmlns:a="http://schemas.openxmlformats.org/drawingml/2006/main" xmlns:r="http://schemas.openxmlformats.org/officeDocument/2006/relationships" xmlns:p="http://schemas.openxmlformats.org/presentationml/2006/main">
   <p:cSld>
     <p:spTree>
@@ -1411,6 +2183,13 @@
           </p:nvPr>
         </p:nvSpPr>
         <p:spPr/>
+        <p:txBody>
+          <a:bodyPr/>
+          <a:lstStyle/>
+          <a:p>
+            <a:endParaRPr lang="zh-CN" altLang="en-US"/>
+          </a:p>
+        </p:txBody>
       </p:sp>
       <p:sp>
         <p:nvSpPr>
@@ -1470,7 +2249,7 @@
             <a:pPr rtl="0"/>
             <a:fld id="{A89C7E07-3C67-C64C-8DA0-0404F6303970}" type="slidenum">
               <a:rPr lang="en-US" altLang="zh-CN" smtClean="0"/>
-              <a:t>7</a:t>
+              <a:t>9</a:t>
             </a:fld>
             <a:endParaRPr lang="zh-CN" dirty="0"/>
           </a:p>
@@ -1480,218 +2259,6 @@
     <p:extLst>
       <p:ext uri="{BB962C8B-B14F-4D97-AF65-F5344CB8AC3E}">
         <p14:creationId xmlns:p14="http://schemas.microsoft.com/office/powerpoint/2010/main" val="1875537880"/>
-      </p:ext>
-    </p:extLst>
-  </p:cSld>
-  <p:clrMapOvr>
-    <a:masterClrMapping/>
-  </p:clrMapOvr>
-</p:notes>
-</file>
-
-<file path=ppt/notesSlides/notesSlide8.xml><?xml version="1.0" encoding="utf-8"?>
-<p:notes xmlns:a="http://schemas.openxmlformats.org/drawingml/2006/main" xmlns:r="http://schemas.openxmlformats.org/officeDocument/2006/relationships" xmlns:p="http://schemas.openxmlformats.org/presentationml/2006/main">
-  <p:cSld>
-    <p:spTree>
-      <p:nvGrpSpPr>
-        <p:cNvPr id="1" name="">
-          <a:extLst>
-            <a:ext uri="{FF2B5EF4-FFF2-40B4-BE49-F238E27FC236}">
-              <a16:creationId xmlns:a16="http://schemas.microsoft.com/office/drawing/2014/main" id="{1B824428-F043-0080-79D9-B80C66689270}"/>
-            </a:ext>
-          </a:extLst>
-        </p:cNvPr>
-        <p:cNvGrpSpPr/>
-        <p:nvPr/>
-      </p:nvGrpSpPr>
-      <p:grpSpPr>
-        <a:xfrm>
-          <a:off x="0" y="0"/>
-          <a:ext cx="0" cy="0"/>
-          <a:chOff x="0" y="0"/>
-          <a:chExt cx="0" cy="0"/>
-        </a:xfrm>
-      </p:grpSpPr>
-      <p:sp>
-        <p:nvSpPr>
-          <p:cNvPr id="2" name="幻灯片图像占位符 1">
-            <a:extLst>
-              <a:ext uri="{FF2B5EF4-FFF2-40B4-BE49-F238E27FC236}">
-                <a16:creationId xmlns:a16="http://schemas.microsoft.com/office/drawing/2014/main" id="{4A6856CE-5354-3689-4F5A-E8C1651018AC}"/>
-              </a:ext>
-            </a:extLst>
-          </p:cNvPr>
-          <p:cNvSpPr>
-            <a:spLocks noGrp="1" noRot="1" noChangeAspect="1"/>
-          </p:cNvSpPr>
-          <p:nvPr>
-            <p:ph type="sldImg"/>
-          </p:nvPr>
-        </p:nvSpPr>
-        <p:spPr/>
-      </p:sp>
-      <p:sp>
-        <p:nvSpPr>
-          <p:cNvPr id="3" name="备注占位符 2">
-            <a:extLst>
-              <a:ext uri="{FF2B5EF4-FFF2-40B4-BE49-F238E27FC236}">
-                <a16:creationId xmlns:a16="http://schemas.microsoft.com/office/drawing/2014/main" id="{D09A3267-8466-7F6E-497D-2920717D9FD3}"/>
-              </a:ext>
-            </a:extLst>
-          </p:cNvPr>
-          <p:cNvSpPr>
-            <a:spLocks noGrp="1"/>
-          </p:cNvSpPr>
-          <p:nvPr>
-            <p:ph type="body" idx="1"/>
-          </p:nvPr>
-        </p:nvSpPr>
-        <p:spPr/>
-        <p:txBody>
-          <a:bodyPr rtlCol="0"/>
-          <a:lstStyle>
-            <a:defPPr>
-              <a:defRPr lang="zh-CN"/>
-            </a:defPPr>
-          </a:lstStyle>
-          <a:p>
-            <a:pPr rtl="0"/>
-            <a:endParaRPr lang="zh-CN" dirty="0"/>
-          </a:p>
-        </p:txBody>
-      </p:sp>
-      <p:sp>
-        <p:nvSpPr>
-          <p:cNvPr id="4" name="幻灯片编号占位符 3">
-            <a:extLst>
-              <a:ext uri="{FF2B5EF4-FFF2-40B4-BE49-F238E27FC236}">
-                <a16:creationId xmlns:a16="http://schemas.microsoft.com/office/drawing/2014/main" id="{48A274E0-A950-9BFC-4BC2-231DB15F2DF7}"/>
-              </a:ext>
-            </a:extLst>
-          </p:cNvPr>
-          <p:cNvSpPr>
-            <a:spLocks noGrp="1"/>
-          </p:cNvSpPr>
-          <p:nvPr>
-            <p:ph type="sldNum" sz="quarter" idx="5"/>
-          </p:nvPr>
-        </p:nvSpPr>
-        <p:spPr/>
-        <p:txBody>
-          <a:bodyPr rtlCol="0"/>
-          <a:lstStyle>
-            <a:defPPr>
-              <a:defRPr lang="zh-CN"/>
-            </a:defPPr>
-          </a:lstStyle>
-          <a:p>
-            <a:pPr rtl="0"/>
-            <a:fld id="{A89C7E07-3C67-C64C-8DA0-0404F6303970}" type="slidenum">
-              <a:rPr lang="en-US" altLang="zh-CN" smtClean="0"/>
-              <a:t>8</a:t>
-            </a:fld>
-            <a:endParaRPr lang="zh-CN" dirty="0"/>
-          </a:p>
-        </p:txBody>
-      </p:sp>
-    </p:spTree>
-    <p:extLst>
-      <p:ext uri="{BB962C8B-B14F-4D97-AF65-F5344CB8AC3E}">
-        <p14:creationId xmlns:p14="http://schemas.microsoft.com/office/powerpoint/2010/main" val="1866824279"/>
-      </p:ext>
-    </p:extLst>
-  </p:cSld>
-  <p:clrMapOvr>
-    <a:masterClrMapping/>
-  </p:clrMapOvr>
-</p:notes>
-</file>
-
-<file path=ppt/notesSlides/notesSlide9.xml><?xml version="1.0" encoding="utf-8"?>
-<p:notes xmlns:a="http://schemas.openxmlformats.org/drawingml/2006/main" xmlns:r="http://schemas.openxmlformats.org/officeDocument/2006/relationships" xmlns:p="http://schemas.openxmlformats.org/presentationml/2006/main">
-  <p:cSld>
-    <p:spTree>
-      <p:nvGrpSpPr>
-        <p:cNvPr id="1" name=""/>
-        <p:cNvGrpSpPr/>
-        <p:nvPr/>
-      </p:nvGrpSpPr>
-      <p:grpSpPr>
-        <a:xfrm>
-          <a:off x="0" y="0"/>
-          <a:ext cx="0" cy="0"/>
-          <a:chOff x="0" y="0"/>
-          <a:chExt cx="0" cy="0"/>
-        </a:xfrm>
-      </p:grpSpPr>
-      <p:sp>
-        <p:nvSpPr>
-          <p:cNvPr id="2" name="幻灯片图像占位符 1"/>
-          <p:cNvSpPr>
-            <a:spLocks noGrp="1" noRot="1" noChangeAspect="1"/>
-          </p:cNvSpPr>
-          <p:nvPr>
-            <p:ph type="sldImg"/>
-          </p:nvPr>
-        </p:nvSpPr>
-        <p:spPr/>
-      </p:sp>
-      <p:sp>
-        <p:nvSpPr>
-          <p:cNvPr id="3" name="备注占位符 2"/>
-          <p:cNvSpPr>
-            <a:spLocks noGrp="1"/>
-          </p:cNvSpPr>
-          <p:nvPr>
-            <p:ph type="body" idx="1"/>
-          </p:nvPr>
-        </p:nvSpPr>
-        <p:spPr/>
-        <p:txBody>
-          <a:bodyPr rtlCol="0"/>
-          <a:lstStyle>
-            <a:defPPr>
-              <a:defRPr lang="zh-CN"/>
-            </a:defPPr>
-          </a:lstStyle>
-          <a:p>
-            <a:pPr rtl="0"/>
-            <a:endParaRPr lang="zh-CN" dirty="0"/>
-          </a:p>
-        </p:txBody>
-      </p:sp>
-      <p:sp>
-        <p:nvSpPr>
-          <p:cNvPr id="4" name="灯片编号占位符 3"/>
-          <p:cNvSpPr>
-            <a:spLocks noGrp="1"/>
-          </p:cNvSpPr>
-          <p:nvPr>
-            <p:ph type="sldNum" sz="quarter" idx="5"/>
-          </p:nvPr>
-        </p:nvSpPr>
-        <p:spPr/>
-        <p:txBody>
-          <a:bodyPr rtlCol="0"/>
-          <a:lstStyle>
-            <a:defPPr>
-              <a:defRPr lang="zh-CN"/>
-            </a:defPPr>
-          </a:lstStyle>
-          <a:p>
-            <a:pPr rtl="0"/>
-            <a:fld id="{A89C7E07-3C67-C64C-8DA0-0404F6303970}" type="slidenum">
-              <a:rPr lang="en-US" altLang="zh-CN" smtClean="0"/>
-              <a:t>9</a:t>
-            </a:fld>
-            <a:endParaRPr lang="zh-CN" dirty="0"/>
-          </a:p>
-        </p:txBody>
-      </p:sp>
-    </p:spTree>
-    <p:extLst>
-      <p:ext uri="{BB962C8B-B14F-4D97-AF65-F5344CB8AC3E}">
-        <p14:creationId xmlns:p14="http://schemas.microsoft.com/office/powerpoint/2010/main" val="1765923172"/>
       </p:ext>
     </p:extLst>
   </p:cSld>
@@ -10562,6 +11129,444 @@
 </p:sld>
 </file>
 
+<file path=ppt/slides/slide10.xml><?xml version="1.0" encoding="utf-8"?>
+<p:sld xmlns:a="http://schemas.openxmlformats.org/drawingml/2006/main" xmlns:r="http://schemas.openxmlformats.org/officeDocument/2006/relationships" xmlns:p="http://schemas.openxmlformats.org/presentationml/2006/main">
+  <p:cSld>
+    <p:spTree>
+      <p:nvGrpSpPr>
+        <p:cNvPr id="1" name="">
+          <a:extLst>
+            <a:ext uri="{FF2B5EF4-FFF2-40B4-BE49-F238E27FC236}">
+              <a16:creationId xmlns:a16="http://schemas.microsoft.com/office/drawing/2014/main" id="{7357C94C-FA9E-38E6-3331-287C1B88EB1E}"/>
+            </a:ext>
+          </a:extLst>
+        </p:cNvPr>
+        <p:cNvGrpSpPr/>
+        <p:nvPr/>
+      </p:nvGrpSpPr>
+      <p:grpSpPr>
+        <a:xfrm>
+          <a:off x="0" y="0"/>
+          <a:ext cx="0" cy="0"/>
+          <a:chOff x="0" y="0"/>
+          <a:chExt cx="0" cy="0"/>
+        </a:xfrm>
+      </p:grpSpPr>
+      <p:sp>
+        <p:nvSpPr>
+          <p:cNvPr id="2" name="标题 1">
+            <a:extLst>
+              <a:ext uri="{FF2B5EF4-FFF2-40B4-BE49-F238E27FC236}">
+                <a16:creationId xmlns:a16="http://schemas.microsoft.com/office/drawing/2014/main" id="{40C8627F-5954-03B0-7423-D3C985252F7C}"/>
+              </a:ext>
+            </a:extLst>
+          </p:cNvPr>
+          <p:cNvSpPr>
+            <a:spLocks noGrp="1"/>
+          </p:cNvSpPr>
+          <p:nvPr>
+            <p:ph type="title"/>
+          </p:nvPr>
+        </p:nvSpPr>
+        <p:spPr>
+          <a:xfrm>
+            <a:off x="594360" y="278129"/>
+            <a:ext cx="9778365" cy="1494596"/>
+          </a:xfrm>
+        </p:spPr>
+        <p:txBody>
+          <a:bodyPr rtlCol="0">
+            <a:normAutofit/>
+          </a:bodyPr>
+          <a:lstStyle>
+            <a:defPPr>
+              <a:defRPr lang="zh-CN"/>
+            </a:defPPr>
+          </a:lstStyle>
+          <a:p>
+            <a:pPr rtl="0"/>
+            <a:r>
+              <a:rPr lang="en-US" altLang="zh-CN" dirty="0"/>
+              <a:t>Task</a:t>
+            </a:r>
+            <a:endParaRPr lang="zh-CN" dirty="0"/>
+          </a:p>
+        </p:txBody>
+      </p:sp>
+      <p:sp>
+        <p:nvSpPr>
+          <p:cNvPr id="3" name="内容占位符 2">
+            <a:extLst>
+              <a:ext uri="{FF2B5EF4-FFF2-40B4-BE49-F238E27FC236}">
+                <a16:creationId xmlns:a16="http://schemas.microsoft.com/office/drawing/2014/main" id="{01055182-6F7C-EECE-B3C6-6B9D382FDEC3}"/>
+              </a:ext>
+            </a:extLst>
+          </p:cNvPr>
+          <p:cNvSpPr>
+            <a:spLocks noGrp="1"/>
+          </p:cNvSpPr>
+          <p:nvPr>
+            <p:ph sz="quarter" idx="15"/>
+          </p:nvPr>
+        </p:nvSpPr>
+        <p:spPr>
+          <a:xfrm>
+            <a:off x="308758" y="2481943"/>
+            <a:ext cx="11679382" cy="3792052"/>
+          </a:xfrm>
+        </p:spPr>
+        <p:txBody>
+          <a:bodyPr rtlCol="0">
+            <a:noAutofit/>
+          </a:bodyPr>
+          <a:lstStyle>
+            <a:defPPr>
+              <a:defRPr lang="zh-CN"/>
+            </a:defPPr>
+          </a:lstStyle>
+          <a:p>
+            <a:r>
+              <a:rPr lang="en-US" altLang="zh-CN" dirty="0">
+                <a:latin typeface="Times New Roman" panose="02020603050405020304" pitchFamily="18" charset="0"/>
+                <a:cs typeface="Times New Roman" panose="02020603050405020304" pitchFamily="18" charset="0"/>
+              </a:rPr>
+              <a:t>Adding content</a:t>
+            </a:r>
+            <a:endParaRPr lang="zh-CN" dirty="0">
+              <a:latin typeface="Times New Roman" panose="02020603050405020304" pitchFamily="18" charset="0"/>
+              <a:cs typeface="Times New Roman" panose="02020603050405020304" pitchFamily="18" charset="0"/>
+            </a:endParaRPr>
+          </a:p>
+        </p:txBody>
+      </p:sp>
+    </p:spTree>
+    <p:extLst>
+      <p:ext uri="{BB962C8B-B14F-4D97-AF65-F5344CB8AC3E}">
+        <p14:creationId xmlns:p14="http://schemas.microsoft.com/office/powerpoint/2010/main" val="723020327"/>
+      </p:ext>
+    </p:extLst>
+  </p:cSld>
+  <p:clrMapOvr>
+    <a:masterClrMapping/>
+  </p:clrMapOvr>
+</p:sld>
+</file>
+
+<file path=ppt/slides/slide11.xml><?xml version="1.0" encoding="utf-8"?>
+<p:sld xmlns:a="http://schemas.openxmlformats.org/drawingml/2006/main" xmlns:r="http://schemas.openxmlformats.org/officeDocument/2006/relationships" xmlns:p="http://schemas.openxmlformats.org/presentationml/2006/main">
+  <p:cSld>
+    <p:spTree>
+      <p:nvGrpSpPr>
+        <p:cNvPr id="1" name="">
+          <a:extLst>
+            <a:ext uri="{FF2B5EF4-FFF2-40B4-BE49-F238E27FC236}">
+              <a16:creationId xmlns:a16="http://schemas.microsoft.com/office/drawing/2014/main" id="{6B6C013C-4755-428A-2A60-9E998F309CE4}"/>
+            </a:ext>
+          </a:extLst>
+        </p:cNvPr>
+        <p:cNvGrpSpPr/>
+        <p:nvPr/>
+      </p:nvGrpSpPr>
+      <p:grpSpPr>
+        <a:xfrm>
+          <a:off x="0" y="0"/>
+          <a:ext cx="0" cy="0"/>
+          <a:chOff x="0" y="0"/>
+          <a:chExt cx="0" cy="0"/>
+        </a:xfrm>
+      </p:grpSpPr>
+      <p:sp>
+        <p:nvSpPr>
+          <p:cNvPr id="9" name="标题 8">
+            <a:extLst>
+              <a:ext uri="{FF2B5EF4-FFF2-40B4-BE49-F238E27FC236}">
+                <a16:creationId xmlns:a16="http://schemas.microsoft.com/office/drawing/2014/main" id="{C9AA9541-1475-EE26-F47A-B549B01A67D6}"/>
+              </a:ext>
+            </a:extLst>
+          </p:cNvPr>
+          <p:cNvSpPr>
+            <a:spLocks noGrp="1"/>
+          </p:cNvSpPr>
+          <p:nvPr>
+            <p:ph type="ctrTitle"/>
+          </p:nvPr>
+        </p:nvSpPr>
+        <p:spPr>
+          <a:xfrm>
+            <a:off x="6309904" y="411479"/>
+            <a:ext cx="5486400" cy="3291840"/>
+          </a:xfrm>
+        </p:spPr>
+        <p:txBody>
+          <a:bodyPr rtlCol="0">
+            <a:normAutofit/>
+          </a:bodyPr>
+          <a:lstStyle>
+            <a:defPPr>
+              <a:defRPr lang="zh-CN"/>
+            </a:defPPr>
+          </a:lstStyle>
+          <a:p>
+            <a:pPr rtl="0"/>
+            <a:r>
+              <a:rPr lang="en-US" altLang="zh-CN" dirty="0"/>
+              <a:t>Task 4</a:t>
+            </a:r>
+            <a:endParaRPr lang="zh-CN" dirty="0"/>
+          </a:p>
+        </p:txBody>
+      </p:sp>
+      <p:sp>
+        <p:nvSpPr>
+          <p:cNvPr id="2" name="文本框 1">
+            <a:extLst>
+              <a:ext uri="{FF2B5EF4-FFF2-40B4-BE49-F238E27FC236}">
+                <a16:creationId xmlns:a16="http://schemas.microsoft.com/office/drawing/2014/main" id="{295045F4-6F3D-5C57-3AC4-68D251E02F36}"/>
+              </a:ext>
+            </a:extLst>
+          </p:cNvPr>
+          <p:cNvSpPr txBox="1"/>
+          <p:nvPr/>
+        </p:nvSpPr>
+        <p:spPr>
+          <a:xfrm>
+            <a:off x="6309904" y="4043548"/>
+            <a:ext cx="5074851" cy="584775"/>
+          </a:xfrm>
+          <a:prstGeom prst="rect">
+            <a:avLst/>
+          </a:prstGeom>
+          <a:noFill/>
+        </p:spPr>
+        <p:txBody>
+          <a:bodyPr wrap="none" rtlCol="0">
+            <a:spAutoFit/>
+          </a:bodyPr>
+          <a:lstStyle/>
+          <a:p>
+            <a:r>
+              <a:rPr lang="en-US" altLang="zh-CN" sz="3200" dirty="0">
+                <a:solidFill>
+                  <a:schemeClr val="bg1"/>
+                </a:solidFill>
+              </a:rPr>
+              <a:t>Further audio improvements</a:t>
+            </a:r>
+            <a:endParaRPr lang="zh-CN" altLang="en-US" sz="3200" dirty="0">
+              <a:solidFill>
+                <a:schemeClr val="bg1"/>
+              </a:solidFill>
+            </a:endParaRPr>
+          </a:p>
+        </p:txBody>
+      </p:sp>
+    </p:spTree>
+    <p:extLst>
+      <p:ext uri="{BB962C8B-B14F-4D97-AF65-F5344CB8AC3E}">
+        <p14:creationId xmlns:p14="http://schemas.microsoft.com/office/powerpoint/2010/main" val="1580619806"/>
+      </p:ext>
+    </p:extLst>
+  </p:cSld>
+  <p:clrMapOvr>
+    <a:masterClrMapping/>
+  </p:clrMapOvr>
+</p:sld>
+</file>
+
+<file path=ppt/slides/slide12.xml><?xml version="1.0" encoding="utf-8"?>
+<p:sld xmlns:a="http://schemas.openxmlformats.org/drawingml/2006/main" xmlns:r="http://schemas.openxmlformats.org/officeDocument/2006/relationships" xmlns:p="http://schemas.openxmlformats.org/presentationml/2006/main">
+  <p:cSld>
+    <p:spTree>
+      <p:nvGrpSpPr>
+        <p:cNvPr id="1" name="">
+          <a:extLst>
+            <a:ext uri="{FF2B5EF4-FFF2-40B4-BE49-F238E27FC236}">
+              <a16:creationId xmlns:a16="http://schemas.microsoft.com/office/drawing/2014/main" id="{3EBAEA52-96FA-323F-1F00-72991D11DD23}"/>
+            </a:ext>
+          </a:extLst>
+        </p:cNvPr>
+        <p:cNvGrpSpPr/>
+        <p:nvPr/>
+      </p:nvGrpSpPr>
+      <p:grpSpPr>
+        <a:xfrm>
+          <a:off x="0" y="0"/>
+          <a:ext cx="0" cy="0"/>
+          <a:chOff x="0" y="0"/>
+          <a:chExt cx="0" cy="0"/>
+        </a:xfrm>
+      </p:grpSpPr>
+      <p:sp>
+        <p:nvSpPr>
+          <p:cNvPr id="2" name="标题 1">
+            <a:extLst>
+              <a:ext uri="{FF2B5EF4-FFF2-40B4-BE49-F238E27FC236}">
+                <a16:creationId xmlns:a16="http://schemas.microsoft.com/office/drawing/2014/main" id="{DFF74755-4E36-0A63-C4EE-9F0473A01BF1}"/>
+              </a:ext>
+            </a:extLst>
+          </p:cNvPr>
+          <p:cNvSpPr>
+            <a:spLocks noGrp="1"/>
+          </p:cNvSpPr>
+          <p:nvPr>
+            <p:ph type="title"/>
+          </p:nvPr>
+        </p:nvSpPr>
+        <p:spPr>
+          <a:xfrm>
+            <a:off x="594360" y="278129"/>
+            <a:ext cx="9778365" cy="1494596"/>
+          </a:xfrm>
+        </p:spPr>
+        <p:txBody>
+          <a:bodyPr rtlCol="0">
+            <a:normAutofit/>
+          </a:bodyPr>
+          <a:lstStyle>
+            <a:defPPr>
+              <a:defRPr lang="zh-CN"/>
+            </a:defPPr>
+          </a:lstStyle>
+          <a:p>
+            <a:pPr rtl="0"/>
+            <a:r>
+              <a:rPr lang="en-US" altLang="zh-CN" dirty="0"/>
+              <a:t>Task</a:t>
+            </a:r>
+            <a:endParaRPr lang="zh-CN" dirty="0"/>
+          </a:p>
+        </p:txBody>
+      </p:sp>
+      <p:sp>
+        <p:nvSpPr>
+          <p:cNvPr id="3" name="内容占位符 2">
+            <a:extLst>
+              <a:ext uri="{FF2B5EF4-FFF2-40B4-BE49-F238E27FC236}">
+                <a16:creationId xmlns:a16="http://schemas.microsoft.com/office/drawing/2014/main" id="{60AE54F5-300F-FC39-8417-4E36553344B8}"/>
+              </a:ext>
+            </a:extLst>
+          </p:cNvPr>
+          <p:cNvSpPr>
+            <a:spLocks noGrp="1"/>
+          </p:cNvSpPr>
+          <p:nvPr>
+            <p:ph sz="quarter" idx="15"/>
+          </p:nvPr>
+        </p:nvSpPr>
+        <p:spPr>
+          <a:xfrm>
+            <a:off x="308758" y="2481943"/>
+            <a:ext cx="11679382" cy="3792052"/>
+          </a:xfrm>
+        </p:spPr>
+        <p:txBody>
+          <a:bodyPr rtlCol="0">
+            <a:noAutofit/>
+          </a:bodyPr>
+          <a:lstStyle>
+            <a:defPPr>
+              <a:defRPr lang="zh-CN"/>
+            </a:defPPr>
+          </a:lstStyle>
+          <a:p>
+            <a:r>
+              <a:rPr lang="en-US" altLang="zh-CN" dirty="0">
+                <a:latin typeface="Times New Roman" panose="02020603050405020304" pitchFamily="18" charset="0"/>
+                <a:cs typeface="Times New Roman" panose="02020603050405020304" pitchFamily="18" charset="0"/>
+              </a:rPr>
+              <a:t>Adding content</a:t>
+            </a:r>
+            <a:endParaRPr lang="zh-CN" dirty="0">
+              <a:latin typeface="Times New Roman" panose="02020603050405020304" pitchFamily="18" charset="0"/>
+              <a:cs typeface="Times New Roman" panose="02020603050405020304" pitchFamily="18" charset="0"/>
+            </a:endParaRPr>
+          </a:p>
+        </p:txBody>
+      </p:sp>
+    </p:spTree>
+    <p:extLst>
+      <p:ext uri="{BB962C8B-B14F-4D97-AF65-F5344CB8AC3E}">
+        <p14:creationId xmlns:p14="http://schemas.microsoft.com/office/powerpoint/2010/main" val="3407494818"/>
+      </p:ext>
+    </p:extLst>
+  </p:cSld>
+  <p:clrMapOvr>
+    <a:masterClrMapping/>
+  </p:clrMapOvr>
+</p:sld>
+</file>
+
+<file path=ppt/slides/slide13.xml><?xml version="1.0" encoding="utf-8"?>
+<p:sld xmlns:a="http://schemas.openxmlformats.org/drawingml/2006/main" xmlns:r="http://schemas.openxmlformats.org/officeDocument/2006/relationships" xmlns:p="http://schemas.openxmlformats.org/presentationml/2006/main">
+  <p:cSld>
+    <p:spTree>
+      <p:nvGrpSpPr>
+        <p:cNvPr id="1" name=""/>
+        <p:cNvGrpSpPr/>
+        <p:nvPr/>
+      </p:nvGrpSpPr>
+      <p:grpSpPr>
+        <a:xfrm>
+          <a:off x="0" y="0"/>
+          <a:ext cx="0" cy="0"/>
+          <a:chOff x="0" y="0"/>
+          <a:chExt cx="0" cy="0"/>
+        </a:xfrm>
+      </p:grpSpPr>
+      <p:sp>
+        <p:nvSpPr>
+          <p:cNvPr id="2" name="标题 1">
+            <a:extLst>
+              <a:ext uri="{FF2B5EF4-FFF2-40B4-BE49-F238E27FC236}">
+                <a16:creationId xmlns:a16="http://schemas.microsoft.com/office/drawing/2014/main" id="{F810C1B7-6E4E-3DEE-50C0-1CA3B14303EE}"/>
+              </a:ext>
+            </a:extLst>
+          </p:cNvPr>
+          <p:cNvSpPr>
+            <a:spLocks noGrp="1"/>
+          </p:cNvSpPr>
+          <p:nvPr>
+            <p:ph type="ctrTitle"/>
+          </p:nvPr>
+        </p:nvSpPr>
+        <p:spPr>
+          <a:xfrm>
+            <a:off x="594360" y="411479"/>
+            <a:ext cx="5486400" cy="3291840"/>
+          </a:xfrm>
+        </p:spPr>
+        <p:txBody>
+          <a:bodyPr rtlCol="0">
+            <a:normAutofit/>
+          </a:bodyPr>
+          <a:lstStyle>
+            <a:defPPr>
+              <a:defRPr lang="zh-CN"/>
+            </a:defPPr>
+          </a:lstStyle>
+          <a:p>
+            <a:pPr rtl="0"/>
+            <a:r>
+              <a:rPr lang="en-US" altLang="zh-CN" dirty="0"/>
+              <a:t>Thx</a:t>
+            </a:r>
+            <a:endParaRPr lang="zh-CN" dirty="0"/>
+          </a:p>
+        </p:txBody>
+      </p:sp>
+    </p:spTree>
+    <p:extLst>
+      <p:ext uri="{BB962C8B-B14F-4D97-AF65-F5344CB8AC3E}">
+        <p14:creationId xmlns:p14="http://schemas.microsoft.com/office/powerpoint/2010/main" val="4261132419"/>
+      </p:ext>
+    </p:extLst>
+  </p:cSld>
+  <p:clrMapOvr>
+    <a:masterClrMapping/>
+  </p:clrMapOvr>
+</p:sld>
+</file>
+
 <file path=ppt/slides/slide2.xml><?xml version="1.0" encoding="utf-8"?>
 <p:sld xmlns:a="http://schemas.openxmlformats.org/drawingml/2006/main" xmlns:r="http://schemas.openxmlformats.org/officeDocument/2006/relationships" xmlns:p="http://schemas.openxmlformats.org/presentationml/2006/main">
   <p:cSld>
@@ -11738,6 +12743,297 @@
         <p:cNvPr id="1" name="">
           <a:extLst>
             <a:ext uri="{FF2B5EF4-FFF2-40B4-BE49-F238E27FC236}">
+              <a16:creationId xmlns:a16="http://schemas.microsoft.com/office/drawing/2014/main" id="{667C3EAE-1F29-5965-23D3-668D30B8D92D}"/>
+            </a:ext>
+          </a:extLst>
+        </p:cNvPr>
+        <p:cNvGrpSpPr/>
+        <p:nvPr/>
+      </p:nvGrpSpPr>
+      <p:grpSpPr>
+        <a:xfrm>
+          <a:off x="0" y="0"/>
+          <a:ext cx="0" cy="0"/>
+          <a:chOff x="0" y="0"/>
+          <a:chExt cx="0" cy="0"/>
+        </a:xfrm>
+      </p:grpSpPr>
+      <p:sp>
+        <p:nvSpPr>
+          <p:cNvPr id="2" name="标题 1">
+            <a:extLst>
+              <a:ext uri="{FF2B5EF4-FFF2-40B4-BE49-F238E27FC236}">
+                <a16:creationId xmlns:a16="http://schemas.microsoft.com/office/drawing/2014/main" id="{51995CF4-299C-3176-15E3-DB69E649C036}"/>
+              </a:ext>
+            </a:extLst>
+          </p:cNvPr>
+          <p:cNvSpPr>
+            <a:spLocks noGrp="1"/>
+          </p:cNvSpPr>
+          <p:nvPr>
+            <p:ph type="title"/>
+          </p:nvPr>
+        </p:nvSpPr>
+        <p:spPr>
+          <a:xfrm>
+            <a:off x="594360" y="278129"/>
+            <a:ext cx="9778365" cy="1494596"/>
+          </a:xfrm>
+        </p:spPr>
+        <p:txBody>
+          <a:bodyPr rtlCol="0">
+            <a:normAutofit/>
+          </a:bodyPr>
+          <a:lstStyle>
+            <a:defPPr>
+              <a:defRPr lang="zh-CN"/>
+            </a:defPPr>
+          </a:lstStyle>
+          <a:p>
+            <a:pPr rtl="0"/>
+            <a:r>
+              <a:rPr lang="en-US" altLang="zh-CN" dirty="0"/>
+              <a:t>Task 2 (user interface and modes)</a:t>
+            </a:r>
+            <a:endParaRPr lang="zh-CN" dirty="0"/>
+          </a:p>
+        </p:txBody>
+      </p:sp>
+      <p:sp>
+        <p:nvSpPr>
+          <p:cNvPr id="3" name="内容占位符 2">
+            <a:extLst>
+              <a:ext uri="{FF2B5EF4-FFF2-40B4-BE49-F238E27FC236}">
+                <a16:creationId xmlns:a16="http://schemas.microsoft.com/office/drawing/2014/main" id="{CDBCF046-EC7F-1525-B528-3B321E07F066}"/>
+              </a:ext>
+            </a:extLst>
+          </p:cNvPr>
+          <p:cNvSpPr>
+            <a:spLocks noGrp="1"/>
+          </p:cNvSpPr>
+          <p:nvPr>
+            <p:ph sz="quarter" idx="15"/>
+          </p:nvPr>
+        </p:nvSpPr>
+        <p:spPr>
+          <a:xfrm>
+            <a:off x="308758" y="2481943"/>
+            <a:ext cx="11679382" cy="3792052"/>
+          </a:xfrm>
+        </p:spPr>
+        <p:txBody>
+          <a:bodyPr rtlCol="0">
+            <a:noAutofit/>
+          </a:bodyPr>
+          <a:lstStyle>
+            <a:defPPr>
+              <a:defRPr lang="zh-CN"/>
+            </a:defPPr>
+          </a:lstStyle>
+          <a:p>
+            <a:r>
+              <a:rPr lang="en-US" altLang="zh-CN" b="1" dirty="0">
+                <a:latin typeface="Times New Roman" panose="02020603050405020304" pitchFamily="18" charset="0"/>
+                <a:cs typeface="Times New Roman" panose="02020603050405020304" pitchFamily="18" charset="0"/>
+              </a:rPr>
+              <a:t>CLI Interface</a:t>
+            </a:r>
+          </a:p>
+          <a:p>
+            <a:r>
+              <a:rPr lang="en-US" altLang="zh-CN" dirty="0">
+                <a:latin typeface="Times New Roman" panose="02020603050405020304" pitchFamily="18" charset="0"/>
+                <a:cs typeface="Times New Roman" panose="02020603050405020304" pitchFamily="18" charset="0"/>
+              </a:rPr>
+              <a:t>•  Extends the Python script into a user-controlled interface.</a:t>
+            </a:r>
+          </a:p>
+          <a:p>
+            <a:r>
+              <a:rPr lang="en-US" altLang="zh-CN" dirty="0">
+                <a:latin typeface="Times New Roman" panose="02020603050405020304" pitchFamily="18" charset="0"/>
+                <a:cs typeface="Times New Roman" panose="02020603050405020304" pitchFamily="18" charset="0"/>
+              </a:rPr>
+              <a:t>•  Supports audio export types as .wav, .png, and .csv waveform files.</a:t>
+            </a:r>
+          </a:p>
+          <a:p>
+            <a:r>
+              <a:rPr lang="en-US" altLang="zh-CN" dirty="0">
+                <a:latin typeface="Times New Roman" panose="02020603050405020304" pitchFamily="18" charset="0"/>
+                <a:cs typeface="Times New Roman" panose="02020603050405020304" pitchFamily="18" charset="0"/>
+              </a:rPr>
+              <a:t>•  Adds two operating modes: “Manual Recording Mode” and “Distance Trigger Mode”.</a:t>
+            </a:r>
+          </a:p>
+          <a:p>
+            <a:r>
+              <a:rPr lang="en-US" altLang="zh-CN" dirty="0">
+                <a:latin typeface="Times New Roman" panose="02020603050405020304" pitchFamily="18" charset="0"/>
+                <a:cs typeface="Times New Roman" panose="02020603050405020304" pitchFamily="18" charset="0"/>
+              </a:rPr>
+              <a:t>•  Manual Mode records for a user-specified duration.</a:t>
+            </a:r>
+          </a:p>
+          <a:p>
+            <a:r>
+              <a:rPr lang="en-US" altLang="zh-CN" dirty="0">
+                <a:latin typeface="Times New Roman" panose="02020603050405020304" pitchFamily="18" charset="0"/>
+                <a:cs typeface="Times New Roman" panose="02020603050405020304" pitchFamily="18" charset="0"/>
+              </a:rPr>
+              <a:t>•  Distance Trigger Mode uses an ultrasonic sensor to automatically record when an object is within the selected range, and when the object leaves the range, the recording stops after a short delay, while the system remains ready to trigger again.</a:t>
+            </a:r>
+            <a:endParaRPr lang="zh-CN" dirty="0">
+              <a:latin typeface="Times New Roman" panose="02020603050405020304" pitchFamily="18" charset="0"/>
+              <a:cs typeface="Times New Roman" panose="02020603050405020304" pitchFamily="18" charset="0"/>
+            </a:endParaRPr>
+          </a:p>
+        </p:txBody>
+      </p:sp>
+    </p:spTree>
+    <p:extLst>
+      <p:ext uri="{BB962C8B-B14F-4D97-AF65-F5344CB8AC3E}">
+        <p14:creationId xmlns:p14="http://schemas.microsoft.com/office/powerpoint/2010/main" val="1965835823"/>
+      </p:ext>
+    </p:extLst>
+  </p:cSld>
+  <p:clrMapOvr>
+    <a:masterClrMapping/>
+  </p:clrMapOvr>
+</p:sld>
+</file>
+
+<file path=ppt/slides/slide8.xml><?xml version="1.0" encoding="utf-8"?>
+<p:sld xmlns:a="http://schemas.openxmlformats.org/drawingml/2006/main" xmlns:r="http://schemas.openxmlformats.org/officeDocument/2006/relationships" xmlns:p="http://schemas.openxmlformats.org/presentationml/2006/main">
+  <p:cSld>
+    <p:spTree>
+      <p:nvGrpSpPr>
+        <p:cNvPr id="1" name="">
+          <a:extLst>
+            <a:ext uri="{FF2B5EF4-FFF2-40B4-BE49-F238E27FC236}">
+              <a16:creationId xmlns:a16="http://schemas.microsoft.com/office/drawing/2014/main" id="{90D10312-246B-80DE-1F41-A75E9525B3A8}"/>
+            </a:ext>
+          </a:extLst>
+        </p:cNvPr>
+        <p:cNvGrpSpPr/>
+        <p:nvPr/>
+      </p:nvGrpSpPr>
+      <p:grpSpPr>
+        <a:xfrm>
+          <a:off x="0" y="0"/>
+          <a:ext cx="0" cy="0"/>
+          <a:chOff x="0" y="0"/>
+          <a:chExt cx="0" cy="0"/>
+        </a:xfrm>
+      </p:grpSpPr>
+      <p:sp>
+        <p:nvSpPr>
+          <p:cNvPr id="2" name="标题 1">
+            <a:extLst>
+              <a:ext uri="{FF2B5EF4-FFF2-40B4-BE49-F238E27FC236}">
+                <a16:creationId xmlns:a16="http://schemas.microsoft.com/office/drawing/2014/main" id="{5A186632-D951-131C-4986-782079B7F620}"/>
+              </a:ext>
+            </a:extLst>
+          </p:cNvPr>
+          <p:cNvSpPr>
+            <a:spLocks noGrp="1"/>
+          </p:cNvSpPr>
+          <p:nvPr>
+            <p:ph type="title"/>
+          </p:nvPr>
+        </p:nvSpPr>
+        <p:spPr>
+          <a:xfrm>
+            <a:off x="594360" y="278129"/>
+            <a:ext cx="9778365" cy="1494596"/>
+          </a:xfrm>
+        </p:spPr>
+        <p:txBody>
+          <a:bodyPr rtlCol="0">
+            <a:normAutofit/>
+          </a:bodyPr>
+          <a:lstStyle>
+            <a:defPPr>
+              <a:defRPr lang="zh-CN"/>
+            </a:defPPr>
+          </a:lstStyle>
+          <a:p>
+            <a:pPr rtl="0"/>
+            <a:r>
+              <a:rPr lang="en-US" altLang="zh-CN" dirty="0"/>
+              <a:t>Task</a:t>
+            </a:r>
+            <a:endParaRPr lang="zh-CN" dirty="0"/>
+          </a:p>
+        </p:txBody>
+      </p:sp>
+      <p:sp>
+        <p:nvSpPr>
+          <p:cNvPr id="3" name="内容占位符 2">
+            <a:extLst>
+              <a:ext uri="{FF2B5EF4-FFF2-40B4-BE49-F238E27FC236}">
+                <a16:creationId xmlns:a16="http://schemas.microsoft.com/office/drawing/2014/main" id="{FECA956C-B419-817F-F979-999267F2D08A}"/>
+              </a:ext>
+            </a:extLst>
+          </p:cNvPr>
+          <p:cNvSpPr>
+            <a:spLocks noGrp="1"/>
+          </p:cNvSpPr>
+          <p:nvPr>
+            <p:ph sz="quarter" idx="15"/>
+          </p:nvPr>
+        </p:nvSpPr>
+        <p:spPr>
+          <a:xfrm>
+            <a:off x="308758" y="2481943"/>
+            <a:ext cx="11679382" cy="3792052"/>
+          </a:xfrm>
+        </p:spPr>
+        <p:txBody>
+          <a:bodyPr rtlCol="0">
+            <a:noAutofit/>
+          </a:bodyPr>
+          <a:lstStyle>
+            <a:defPPr>
+              <a:defRPr lang="zh-CN"/>
+            </a:defPPr>
+          </a:lstStyle>
+          <a:p>
+            <a:r>
+              <a:rPr lang="en-US" altLang="zh-CN" dirty="0">
+                <a:latin typeface="Times New Roman" panose="02020603050405020304" pitchFamily="18" charset="0"/>
+                <a:cs typeface="Times New Roman" panose="02020603050405020304" pitchFamily="18" charset="0"/>
+              </a:rPr>
+              <a:t>Adding content</a:t>
+            </a:r>
+            <a:endParaRPr lang="zh-CN" dirty="0">
+              <a:latin typeface="Times New Roman" panose="02020603050405020304" pitchFamily="18" charset="0"/>
+              <a:cs typeface="Times New Roman" panose="02020603050405020304" pitchFamily="18" charset="0"/>
+            </a:endParaRPr>
+          </a:p>
+        </p:txBody>
+      </p:sp>
+    </p:spTree>
+    <p:extLst>
+      <p:ext uri="{BB962C8B-B14F-4D97-AF65-F5344CB8AC3E}">
+        <p14:creationId xmlns:p14="http://schemas.microsoft.com/office/powerpoint/2010/main" val="3485561479"/>
+      </p:ext>
+    </p:extLst>
+  </p:cSld>
+  <p:clrMapOvr>
+    <a:masterClrMapping/>
+  </p:clrMapOvr>
+</p:sld>
+</file>
+
+<file path=ppt/slides/slide9.xml><?xml version="1.0" encoding="utf-8"?>
+<p:sld xmlns:a="http://schemas.openxmlformats.org/drawingml/2006/main" xmlns:r="http://schemas.openxmlformats.org/officeDocument/2006/relationships" xmlns:p="http://schemas.openxmlformats.org/presentationml/2006/main">
+  <p:cSld>
+    <p:spTree>
+      <p:nvGrpSpPr>
+        <p:cNvPr id="1" name="">
+          <a:extLst>
+            <a:ext uri="{FF2B5EF4-FFF2-40B4-BE49-F238E27FC236}">
               <a16:creationId xmlns:a16="http://schemas.microsoft.com/office/drawing/2014/main" id="{9ED6C000-16B1-494D-ECA7-D34562220B90}"/>
             </a:ext>
           </a:extLst>
@@ -11809,7 +13105,7 @@
         <p:spPr>
           <a:xfrm>
             <a:off x="6454239" y="4471060"/>
-            <a:ext cx="3516925" cy="584775"/>
+            <a:ext cx="3707682" cy="584775"/>
           </a:xfrm>
           <a:prstGeom prst="rect">
             <a:avLst/>
@@ -11828,7 +13124,7 @@
                   <a:schemeClr val="bg1"/>
                 </a:solidFill>
               </a:rPr>
-              <a:t>Audio improvement</a:t>
+              <a:t>Audio improvements</a:t>
             </a:r>
             <a:endParaRPr lang="zh-CN" altLang="en-US" sz="3200" dirty="0">
               <a:solidFill>
@@ -11842,154 +13138,6 @@
     <p:extLst>
       <p:ext uri="{BB962C8B-B14F-4D97-AF65-F5344CB8AC3E}">
         <p14:creationId xmlns:p14="http://schemas.microsoft.com/office/powerpoint/2010/main" val="1927935153"/>
-      </p:ext>
-    </p:extLst>
-  </p:cSld>
-  <p:clrMapOvr>
-    <a:masterClrMapping/>
-  </p:clrMapOvr>
-</p:sld>
-</file>
-
-<file path=ppt/slides/slide8.xml><?xml version="1.0" encoding="utf-8"?>
-<p:sld xmlns:a="http://schemas.openxmlformats.org/drawingml/2006/main" xmlns:r="http://schemas.openxmlformats.org/officeDocument/2006/relationships" xmlns:p="http://schemas.openxmlformats.org/presentationml/2006/main">
-  <p:cSld>
-    <p:spTree>
-      <p:nvGrpSpPr>
-        <p:cNvPr id="1" name="">
-          <a:extLst>
-            <a:ext uri="{FF2B5EF4-FFF2-40B4-BE49-F238E27FC236}">
-              <a16:creationId xmlns:a16="http://schemas.microsoft.com/office/drawing/2014/main" id="{6B6C013C-4755-428A-2A60-9E998F309CE4}"/>
-            </a:ext>
-          </a:extLst>
-        </p:cNvPr>
-        <p:cNvGrpSpPr/>
-        <p:nvPr/>
-      </p:nvGrpSpPr>
-      <p:grpSpPr>
-        <a:xfrm>
-          <a:off x="0" y="0"/>
-          <a:ext cx="0" cy="0"/>
-          <a:chOff x="0" y="0"/>
-          <a:chExt cx="0" cy="0"/>
-        </a:xfrm>
-      </p:grpSpPr>
-      <p:sp>
-        <p:nvSpPr>
-          <p:cNvPr id="9" name="标题 8">
-            <a:extLst>
-              <a:ext uri="{FF2B5EF4-FFF2-40B4-BE49-F238E27FC236}">
-                <a16:creationId xmlns:a16="http://schemas.microsoft.com/office/drawing/2014/main" id="{C9AA9541-1475-EE26-F47A-B549B01A67D6}"/>
-              </a:ext>
-            </a:extLst>
-          </p:cNvPr>
-          <p:cNvSpPr>
-            <a:spLocks noGrp="1"/>
-          </p:cNvSpPr>
-          <p:nvPr>
-            <p:ph type="ctrTitle"/>
-          </p:nvPr>
-        </p:nvSpPr>
-        <p:spPr>
-          <a:xfrm>
-            <a:off x="6309904" y="411479"/>
-            <a:ext cx="5486400" cy="3291840"/>
-          </a:xfrm>
-        </p:spPr>
-        <p:txBody>
-          <a:bodyPr rtlCol="0">
-            <a:normAutofit/>
-          </a:bodyPr>
-          <a:lstStyle>
-            <a:defPPr>
-              <a:defRPr lang="zh-CN"/>
-            </a:defPPr>
-          </a:lstStyle>
-          <a:p>
-            <a:pPr rtl="0"/>
-            <a:r>
-              <a:rPr lang="en-US" altLang="zh-CN" dirty="0"/>
-              <a:t>Task 1 (MVP)</a:t>
-            </a:r>
-            <a:endParaRPr lang="zh-CN" dirty="0"/>
-          </a:p>
-        </p:txBody>
-      </p:sp>
-    </p:spTree>
-    <p:extLst>
-      <p:ext uri="{BB962C8B-B14F-4D97-AF65-F5344CB8AC3E}">
-        <p14:creationId xmlns:p14="http://schemas.microsoft.com/office/powerpoint/2010/main" val="1580619806"/>
-      </p:ext>
-    </p:extLst>
-  </p:cSld>
-  <p:clrMapOvr>
-    <a:masterClrMapping/>
-  </p:clrMapOvr>
-</p:sld>
-</file>
-
-<file path=ppt/slides/slide9.xml><?xml version="1.0" encoding="utf-8"?>
-<p:sld xmlns:a="http://schemas.openxmlformats.org/drawingml/2006/main" xmlns:r="http://schemas.openxmlformats.org/officeDocument/2006/relationships" xmlns:p="http://schemas.openxmlformats.org/presentationml/2006/main">
-  <p:cSld>
-    <p:spTree>
-      <p:nvGrpSpPr>
-        <p:cNvPr id="1" name=""/>
-        <p:cNvGrpSpPr/>
-        <p:nvPr/>
-      </p:nvGrpSpPr>
-      <p:grpSpPr>
-        <a:xfrm>
-          <a:off x="0" y="0"/>
-          <a:ext cx="0" cy="0"/>
-          <a:chOff x="0" y="0"/>
-          <a:chExt cx="0" cy="0"/>
-        </a:xfrm>
-      </p:grpSpPr>
-      <p:sp>
-        <p:nvSpPr>
-          <p:cNvPr id="2" name="标题 1">
-            <a:extLst>
-              <a:ext uri="{FF2B5EF4-FFF2-40B4-BE49-F238E27FC236}">
-                <a16:creationId xmlns:a16="http://schemas.microsoft.com/office/drawing/2014/main" id="{F810C1B7-6E4E-3DEE-50C0-1CA3B14303EE}"/>
-              </a:ext>
-            </a:extLst>
-          </p:cNvPr>
-          <p:cNvSpPr>
-            <a:spLocks noGrp="1"/>
-          </p:cNvSpPr>
-          <p:nvPr>
-            <p:ph type="ctrTitle"/>
-          </p:nvPr>
-        </p:nvSpPr>
-        <p:spPr>
-          <a:xfrm>
-            <a:off x="594360" y="411479"/>
-            <a:ext cx="5486400" cy="3291840"/>
-          </a:xfrm>
-        </p:spPr>
-        <p:txBody>
-          <a:bodyPr rtlCol="0">
-            <a:normAutofit/>
-          </a:bodyPr>
-          <a:lstStyle>
-            <a:defPPr>
-              <a:defRPr lang="zh-CN"/>
-            </a:defPPr>
-          </a:lstStyle>
-          <a:p>
-            <a:pPr rtl="0"/>
-            <a:r>
-              <a:rPr lang="en-US" altLang="zh-CN"/>
-              <a:t>Thx</a:t>
-            </a:r>
-            <a:endParaRPr lang="zh-CN" dirty="0"/>
-          </a:p>
-        </p:txBody>
-      </p:sp>
-    </p:spTree>
-    <p:extLst>
-      <p:ext uri="{BB962C8B-B14F-4D97-AF65-F5344CB8AC3E}">
-        <p14:creationId xmlns:p14="http://schemas.microsoft.com/office/powerpoint/2010/main" val="4261132419"/>
       </p:ext>
     </p:extLst>
   </p:cSld>

</xml_diff>

<commit_message>
block diagram for t1
...
</commit_message>
<xml_diff>
--- a/ECE2071_Project_F08_PPTslides.pptx
+++ b/ECE2071_Project_F08_PPTslides.pptx
@@ -12765,7 +12765,7 @@
         </p:nvSpPr>
         <p:spPr>
           <a:xfrm>
-            <a:off x="6096000" y="920337"/>
+            <a:off x="6096000" y="0"/>
             <a:ext cx="5171110" cy="721759"/>
           </a:xfrm>
         </p:spPr>
@@ -12811,8 +12811,44 @@
         </p:blipFill>
         <p:spPr>
           <a:xfrm>
-            <a:off x="90679" y="0"/>
-            <a:ext cx="5847347" cy="6858000"/>
+            <a:off x="4281055" y="721759"/>
+            <a:ext cx="5228162" cy="6131795"/>
+          </a:xfrm>
+          <a:prstGeom prst="rect">
+            <a:avLst/>
+          </a:prstGeom>
+        </p:spPr>
+      </p:pic>
+      <p:pic>
+        <p:nvPicPr>
+          <p:cNvPr id="7" name="图片 6">
+            <a:extLst>
+              <a:ext uri="{FF2B5EF4-FFF2-40B4-BE49-F238E27FC236}">
+                <a16:creationId xmlns:a16="http://schemas.microsoft.com/office/drawing/2014/main" id="{1572BE20-CF18-80E1-ED51-B8240462F062}"/>
+              </a:ext>
+            </a:extLst>
+          </p:cNvPr>
+          <p:cNvPicPr>
+            <a:picLocks noChangeAspect="1"/>
+          </p:cNvPicPr>
+          <p:nvPr/>
+        </p:nvPicPr>
+        <p:blipFill>
+          <a:blip r:embed="rId3">
+            <a:extLst>
+              <a:ext uri="{28A0092B-C50C-407E-A947-70E740481C1C}">
+                <a14:useLocalDpi xmlns:a14="http://schemas.microsoft.com/office/drawing/2010/main" val="0"/>
+              </a:ext>
+            </a:extLst>
+          </a:blip>
+          <a:stretch>
+            <a:fillRect/>
+          </a:stretch>
+        </p:blipFill>
+        <p:spPr>
+          <a:xfrm>
+            <a:off x="0" y="0"/>
+            <a:ext cx="4281055" cy="6853554"/>
           </a:xfrm>
           <a:prstGeom prst="rect">
             <a:avLst/>
@@ -14042,6 +14078,35 @@
 </file>
 
 <file path=customXml/item1.xml><?xml version="1.0" encoding="utf-8"?>
+<?mso-contentType ?>
+<FormTemplates xmlns="http://schemas.microsoft.com/sharepoint/v3/contenttype/forms">
+  <Display>DocumentLibraryForm</Display>
+  <Edit>DocumentLibraryForm</Edit>
+  <New>DocumentLibraryForm</New>
+</FormTemplates>
+</file>
+
+<file path=customXml/item2.xml><?xml version="1.0" encoding="utf-8"?>
+<p:properties xmlns:p="http://schemas.microsoft.com/office/2006/metadata/properties" xmlns:xsi="http://www.w3.org/2001/XMLSchema-instance" xmlns:pc="http://schemas.microsoft.com/office/infopath/2007/PartnerControls">
+  <documentManagement>
+    <Background xmlns="71af3243-3dd4-4a8d-8c0d-dd76da1f02a5">false</Background>
+    <Status xmlns="71af3243-3dd4-4a8d-8c0d-dd76da1f02a5">Not started</Status>
+    <_ip_UnifiedCompliancePolicyUIAction xmlns="http://schemas.microsoft.com/sharepoint/v3" xsi:nil="true"/>
+    <Image xmlns="71af3243-3dd4-4a8d-8c0d-dd76da1f02a5">
+      <Url xsi:nil="true"/>
+      <Description xsi:nil="true"/>
+    </Image>
+    <_ip_UnifiedCompliancePolicyProperties xmlns="http://schemas.microsoft.com/sharepoint/v3" xsi:nil="true"/>
+    <ImageTagsTaxHTField xmlns="71af3243-3dd4-4a8d-8c0d-dd76da1f02a5">
+      <Terms xmlns="http://schemas.microsoft.com/office/infopath/2007/PartnerControls"/>
+    </ImageTagsTaxHTField>
+    <TaxCatchAll xmlns="230e9df3-be65-4c73-a93b-d1236ebd677e" xsi:nil="true"/>
+    <MediaServiceKeyPoints xmlns="71af3243-3dd4-4a8d-8c0d-dd76da1f02a5" xsi:nil="true"/>
+  </documentManagement>
+</p:properties>
+</file>
+
+<file path=customXml/item3.xml><?xml version="1.0" encoding="utf-8"?>
 <ct:contentTypeSchema xmlns:ct="http://schemas.microsoft.com/office/2006/metadata/contentType" xmlns:ma="http://schemas.microsoft.com/office/2006/metadata/properties/metaAttributes" ct:_="" ma:_="" ma:contentTypeName="Document" ma:contentTypeID="0x01010079F111ED35F8CC479449609E8A0923A6" ma:contentTypeVersion="28" ma:contentTypeDescription="Create a new document." ma:contentTypeScope="" ma:versionID="60f5a4f2d2b0abadcf532d48ebf9cb71">
   <xsd:schema xmlns:xsd="http://www.w3.org/2001/XMLSchema" xmlns:xs="http://www.w3.org/2001/XMLSchema" xmlns:p="http://schemas.microsoft.com/office/2006/metadata/properties" xmlns:ns1="http://schemas.microsoft.com/sharepoint/v3" xmlns:ns2="71af3243-3dd4-4a8d-8c0d-dd76da1f02a5" xmlns:ns3="16c05727-aa75-4e4a-9b5f-8a80a1165891" xmlns:ns4="230e9df3-be65-4c73-a93b-d1236ebd677e" targetNamespace="http://schemas.microsoft.com/office/2006/metadata/properties" ma:root="true" ma:fieldsID="7dd78129e6a1811f84807ad11c651531" ns1:_="" ns2:_="" ns3:_="" ns4:_="">
     <xsd:import namespace="http://schemas.microsoft.com/sharepoint/v3"/>
@@ -14353,36 +14418,27 @@
 </ct:contentTypeSchema>
 </file>
 
-<file path=customXml/item2.xml><?xml version="1.0" encoding="utf-8"?>
-<p:properties xmlns:p="http://schemas.microsoft.com/office/2006/metadata/properties" xmlns:xsi="http://www.w3.org/2001/XMLSchema-instance" xmlns:pc="http://schemas.microsoft.com/office/infopath/2007/PartnerControls">
-  <documentManagement>
-    <Background xmlns="71af3243-3dd4-4a8d-8c0d-dd76da1f02a5">false</Background>
-    <Status xmlns="71af3243-3dd4-4a8d-8c0d-dd76da1f02a5">Not started</Status>
-    <_ip_UnifiedCompliancePolicyUIAction xmlns="http://schemas.microsoft.com/sharepoint/v3" xsi:nil="true"/>
-    <Image xmlns="71af3243-3dd4-4a8d-8c0d-dd76da1f02a5">
-      <Url xsi:nil="true"/>
-      <Description xsi:nil="true"/>
-    </Image>
-    <_ip_UnifiedCompliancePolicyProperties xmlns="http://schemas.microsoft.com/sharepoint/v3" xsi:nil="true"/>
-    <ImageTagsTaxHTField xmlns="71af3243-3dd4-4a8d-8c0d-dd76da1f02a5">
-      <Terms xmlns="http://schemas.microsoft.com/office/infopath/2007/PartnerControls"/>
-    </ImageTagsTaxHTField>
-    <TaxCatchAll xmlns="230e9df3-be65-4c73-a93b-d1236ebd677e" xsi:nil="true"/>
-    <MediaServiceKeyPoints xmlns="71af3243-3dd4-4a8d-8c0d-dd76da1f02a5" xsi:nil="true"/>
-  </documentManagement>
-</p:properties>
+<file path=customXml/itemProps1.xml><?xml version="1.0" encoding="utf-8"?>
+<ds:datastoreItem xmlns:ds="http://schemas.openxmlformats.org/officeDocument/2006/customXml" ds:itemID="{C21FFAC0-05A2-416A-B06C-C248395482CF}">
+  <ds:schemaRefs>
+    <ds:schemaRef ds:uri="http://schemas.microsoft.com/sharepoint/v3/contenttype/forms"/>
+  </ds:schemaRefs>
+</ds:datastoreItem>
 </file>
 
-<file path=customXml/item3.xml><?xml version="1.0" encoding="utf-8"?>
-<?mso-contentType ?>
-<FormTemplates xmlns="http://schemas.microsoft.com/sharepoint/v3/contenttype/forms">
-  <Display>DocumentLibraryForm</Display>
-  <Edit>DocumentLibraryForm</Edit>
-  <New>DocumentLibraryForm</New>
-</FormTemplates>
+<file path=customXml/itemProps2.xml><?xml version="1.0" encoding="utf-8"?>
+<ds:datastoreItem xmlns:ds="http://schemas.openxmlformats.org/officeDocument/2006/customXml" ds:itemID="{4F4B194E-8B30-4377-8C59-ECFB902D2A26}">
+  <ds:schemaRefs>
+    <ds:schemaRef ds:uri="http://schemas.microsoft.com/office/2006/metadata/properties"/>
+    <ds:schemaRef ds:uri="http://schemas.microsoft.com/office/infopath/2007/PartnerControls"/>
+    <ds:schemaRef ds:uri="71af3243-3dd4-4a8d-8c0d-dd76da1f02a5"/>
+    <ds:schemaRef ds:uri="http://schemas.microsoft.com/sharepoint/v3"/>
+    <ds:schemaRef ds:uri="230e9df3-be65-4c73-a93b-d1236ebd677e"/>
+  </ds:schemaRefs>
+</ds:datastoreItem>
 </file>
 
-<file path=customXml/itemProps1.xml><?xml version="1.0" encoding="utf-8"?>
+<file path=customXml/itemProps3.xml><?xml version="1.0" encoding="utf-8"?>
 <ds:datastoreItem xmlns:ds="http://schemas.openxmlformats.org/officeDocument/2006/customXml" ds:itemID="{92DB9E12-8AC3-4138-BF4D-720A5525AB10}">
   <ds:schemaRefs>
     <ds:schemaRef ds:uri="http://schemas.microsoft.com/office/2006/metadata/contentType"/>
@@ -14403,26 +14459,6 @@
 </ds:datastoreItem>
 </file>
 
-<file path=customXml/itemProps2.xml><?xml version="1.0" encoding="utf-8"?>
-<ds:datastoreItem xmlns:ds="http://schemas.openxmlformats.org/officeDocument/2006/customXml" ds:itemID="{4F4B194E-8B30-4377-8C59-ECFB902D2A26}">
-  <ds:schemaRefs>
-    <ds:schemaRef ds:uri="http://schemas.microsoft.com/office/2006/metadata/properties"/>
-    <ds:schemaRef ds:uri="http://schemas.microsoft.com/office/infopath/2007/PartnerControls"/>
-    <ds:schemaRef ds:uri="71af3243-3dd4-4a8d-8c0d-dd76da1f02a5"/>
-    <ds:schemaRef ds:uri="http://schemas.microsoft.com/sharepoint/v3"/>
-    <ds:schemaRef ds:uri="230e9df3-be65-4c73-a93b-d1236ebd677e"/>
-  </ds:schemaRefs>
-</ds:datastoreItem>
-</file>
-
-<file path=customXml/itemProps3.xml><?xml version="1.0" encoding="utf-8"?>
-<ds:datastoreItem xmlns:ds="http://schemas.openxmlformats.org/officeDocument/2006/customXml" ds:itemID="{C21FFAC0-05A2-416A-B06C-C248395482CF}">
-  <ds:schemaRefs>
-    <ds:schemaRef ds:uri="http://schemas.microsoft.com/sharepoint/v3/contenttype/forms"/>
-  </ds:schemaRefs>
-</ds:datastoreItem>
-</file>
-
 <file path=docMetadata/LabelInfo.xml><?xml version="1.0" encoding="utf-8"?>
 <clbl:labelList xmlns:clbl="http://schemas.microsoft.com/office/2020/mipLabelMetadata"/>
 </file>
</xml_diff>

<commit_message>
task 2 block diagram added
..
</commit_message>
<xml_diff>
--- a/ECE2071_Project_F08_PPTslides.pptx
+++ b/ECE2071_Project_F08_PPTslides.pptx
@@ -13204,8 +13204,8 @@
         </p:nvSpPr>
         <p:spPr>
           <a:xfrm>
-            <a:off x="594360" y="278129"/>
-            <a:ext cx="9778365" cy="1494596"/>
+            <a:off x="0" y="0"/>
+            <a:ext cx="9778365" cy="680195"/>
           </a:xfrm>
         </p:spPr>
         <p:txBody>
@@ -13221,58 +13221,48 @@
             <a:pPr rtl="0"/>
             <a:r>
               <a:rPr lang="en-US" altLang="zh-CN" dirty="0"/>
-              <a:t>Task</a:t>
+              <a:t>Task 2 block diagram (CLI)</a:t>
             </a:r>
             <a:endParaRPr lang="zh-CN" dirty="0"/>
           </a:p>
         </p:txBody>
       </p:sp>
-      <p:sp>
-        <p:nvSpPr>
-          <p:cNvPr id="3" name="内容占位符 2">
+      <p:pic>
+        <p:nvPicPr>
+          <p:cNvPr id="8" name="图片 7">
             <a:extLst>
               <a:ext uri="{FF2B5EF4-FFF2-40B4-BE49-F238E27FC236}">
-                <a16:creationId xmlns:a16="http://schemas.microsoft.com/office/drawing/2014/main" id="{FECA956C-B419-817F-F979-999267F2D08A}"/>
+                <a16:creationId xmlns:a16="http://schemas.microsoft.com/office/drawing/2014/main" id="{31760560-CD01-7B8A-F0D0-01B4314C2E5B}"/>
               </a:ext>
             </a:extLst>
           </p:cNvPr>
-          <p:cNvSpPr>
-            <a:spLocks noGrp="1"/>
-          </p:cNvSpPr>
-          <p:nvPr>
-            <p:ph sz="quarter" idx="15"/>
-          </p:nvPr>
-        </p:nvSpPr>
+          <p:cNvPicPr>
+            <a:picLocks noChangeAspect="1"/>
+          </p:cNvPicPr>
+          <p:nvPr/>
+        </p:nvPicPr>
+        <p:blipFill>
+          <a:blip r:embed="rId3">
+            <a:extLst>
+              <a:ext uri="{28A0092B-C50C-407E-A947-70E740481C1C}">
+                <a14:useLocalDpi xmlns:a14="http://schemas.microsoft.com/office/drawing/2010/main" val="0"/>
+              </a:ext>
+            </a:extLst>
+          </a:blip>
+          <a:stretch>
+            <a:fillRect/>
+          </a:stretch>
+        </p:blipFill>
         <p:spPr>
           <a:xfrm>
-            <a:off x="308758" y="2481943"/>
-            <a:ext cx="11679382" cy="3792052"/>
+            <a:off x="77704" y="678007"/>
+            <a:ext cx="7860951" cy="6179993"/>
           </a:xfrm>
+          <a:prstGeom prst="rect">
+            <a:avLst/>
+          </a:prstGeom>
         </p:spPr>
-        <p:txBody>
-          <a:bodyPr rtlCol="0">
-            <a:noAutofit/>
-          </a:bodyPr>
-          <a:lstStyle>
-            <a:defPPr>
-              <a:defRPr lang="zh-CN"/>
-            </a:defPPr>
-          </a:lstStyle>
-          <a:p>
-            <a:r>
-              <a:rPr lang="en-US" altLang="zh-CN" dirty="0">
-                <a:latin typeface="Times New Roman" panose="02020603050405020304" pitchFamily="18" charset="0"/>
-                <a:cs typeface="Times New Roman" panose="02020603050405020304" pitchFamily="18" charset="0"/>
-              </a:rPr>
-              <a:t>Adding content</a:t>
-            </a:r>
-            <a:endParaRPr lang="zh-CN" dirty="0">
-              <a:latin typeface="Times New Roman" panose="02020603050405020304" pitchFamily="18" charset="0"/>
-              <a:cs typeface="Times New Roman" panose="02020603050405020304" pitchFamily="18" charset="0"/>
-            </a:endParaRPr>
-          </a:p>
-        </p:txBody>
-      </p:sp>
+      </p:pic>
     </p:spTree>
     <p:extLst>
       <p:ext uri="{BB962C8B-B14F-4D97-AF65-F5344CB8AC3E}">

</xml_diff>

<commit_message>
task 4 block diagram added
t4 block diagram and short explanation
</commit_message>
<xml_diff>
--- a/ECE2071_Project_F08_PPTslides.pptx
+++ b/ECE2071_Project_F08_PPTslides.pptx
@@ -11536,8 +11536,8 @@
         </p:nvSpPr>
         <p:spPr>
           <a:xfrm>
-            <a:off x="594360" y="278129"/>
-            <a:ext cx="9778365" cy="1494596"/>
+            <a:off x="5082638" y="0"/>
+            <a:ext cx="6321260" cy="650507"/>
           </a:xfrm>
         </p:spPr>
         <p:txBody>
@@ -11553,54 +11553,127 @@
             <a:pPr rtl="0"/>
             <a:r>
               <a:rPr lang="en-US" altLang="zh-CN" dirty="0"/>
-              <a:t>Task</a:t>
+              <a:t>Task 4 block diagram</a:t>
             </a:r>
             <a:endParaRPr lang="zh-CN" dirty="0"/>
           </a:p>
         </p:txBody>
       </p:sp>
-      <p:sp>
-        <p:nvSpPr>
-          <p:cNvPr id="3" name="内容占位符 2">
+      <p:pic>
+        <p:nvPicPr>
+          <p:cNvPr id="5" name="内容占位符 4">
             <a:extLst>
               <a:ext uri="{FF2B5EF4-FFF2-40B4-BE49-F238E27FC236}">
-                <a16:creationId xmlns:a16="http://schemas.microsoft.com/office/drawing/2014/main" id="{60AE54F5-300F-FC39-8417-4E36553344B8}"/>
+                <a16:creationId xmlns:a16="http://schemas.microsoft.com/office/drawing/2014/main" id="{275DBB88-9339-726E-2638-037A80B284E2}"/>
               </a:ext>
             </a:extLst>
           </p:cNvPr>
-          <p:cNvSpPr>
-            <a:spLocks noGrp="1"/>
-          </p:cNvSpPr>
+          <p:cNvPicPr>
+            <a:picLocks noGrp="1" noChangeAspect="1"/>
+          </p:cNvPicPr>
           <p:nvPr>
             <p:ph sz="quarter" idx="15"/>
           </p:nvPr>
+        </p:nvPicPr>
+        <p:blipFill>
+          <a:blip r:embed="rId3">
+            <a:extLst>
+              <a:ext uri="{28A0092B-C50C-407E-A947-70E740481C1C}">
+                <a14:useLocalDpi xmlns:a14="http://schemas.microsoft.com/office/drawing/2010/main" val="0"/>
+              </a:ext>
+            </a:extLst>
+          </a:blip>
+          <a:stretch>
+            <a:fillRect/>
+          </a:stretch>
+        </p:blipFill>
+        <p:spPr>
+          <a:xfrm>
+            <a:off x="-1" y="0"/>
+            <a:ext cx="5082639" cy="6857999"/>
+          </a:xfrm>
+          <a:prstGeom prst="rect">
+            <a:avLst/>
+          </a:prstGeom>
+        </p:spPr>
+      </p:pic>
+      <p:sp>
+        <p:nvSpPr>
+          <p:cNvPr id="6" name="文本框 5">
+            <a:extLst>
+              <a:ext uri="{FF2B5EF4-FFF2-40B4-BE49-F238E27FC236}">
+                <a16:creationId xmlns:a16="http://schemas.microsoft.com/office/drawing/2014/main" id="{31909D27-95BA-A441-8A1B-7A5C21DA8797}"/>
+              </a:ext>
+            </a:extLst>
+          </p:cNvPr>
+          <p:cNvSpPr txBox="1"/>
+          <p:nvPr/>
         </p:nvSpPr>
         <p:spPr>
           <a:xfrm>
-            <a:off x="308758" y="2481943"/>
-            <a:ext cx="11679382" cy="3792052"/>
+            <a:off x="5082638" y="2351316"/>
+            <a:ext cx="6244069" cy="2308324"/>
           </a:xfrm>
+          <a:prstGeom prst="rect">
+            <a:avLst/>
+          </a:prstGeom>
+          <a:noFill/>
         </p:spPr>
         <p:txBody>
-          <a:bodyPr rtlCol="0">
-            <a:noAutofit/>
+          <a:bodyPr wrap="square" rtlCol="0">
+            <a:spAutoFit/>
           </a:bodyPr>
-          <a:lstStyle>
-            <a:defPPr>
-              <a:defRPr lang="zh-CN"/>
-            </a:defPPr>
-          </a:lstStyle>
+          <a:lstStyle/>
           <a:p>
             <a:r>
               <a:rPr lang="en-US" altLang="zh-CN" dirty="0">
-                <a:latin typeface="Times New Roman" panose="02020603050405020304" pitchFamily="18" charset="0"/>
-                <a:cs typeface="Times New Roman" panose="02020603050405020304" pitchFamily="18" charset="0"/>
+                <a:solidFill>
+                  <a:schemeClr val="bg1"/>
+                </a:solidFill>
               </a:rPr>
-              <a:t>Adding content</a:t>
+              <a:t>Sampling STM:</a:t>
             </a:r>
-            <a:endParaRPr lang="zh-CN" dirty="0">
-              <a:latin typeface="Times New Roman" panose="02020603050405020304" pitchFamily="18" charset="0"/>
-              <a:cs typeface="Times New Roman" panose="02020603050405020304" pitchFamily="18" charset="0"/>
+          </a:p>
+          <a:p>
+            <a:r>
+              <a:rPr lang="en-US" altLang="zh-CN" dirty="0">
+                <a:solidFill>
+                  <a:schemeClr val="bg1"/>
+                </a:solidFill>
+              </a:rPr>
+              <a:t>takes in 12-bit ADC at 44.138 ksps, using SPI to send sample to process in a 16-bit frame</a:t>
+            </a:r>
+          </a:p>
+          <a:p>
+            <a:endParaRPr lang="en-US" altLang="zh-CN" dirty="0">
+              <a:solidFill>
+                <a:schemeClr val="bg1"/>
+              </a:solidFill>
+            </a:endParaRPr>
+          </a:p>
+          <a:p>
+            <a:r>
+              <a:rPr lang="en-US" altLang="zh-CN" dirty="0">
+                <a:solidFill>
+                  <a:schemeClr val="bg1"/>
+                </a:solidFill>
+              </a:rPr>
+              <a:t>Processing STM:</a:t>
+            </a:r>
+          </a:p>
+          <a:p>
+            <a:r>
+              <a:rPr lang="en-US" altLang="zh-CN" dirty="0">
+                <a:solidFill>
+                  <a:schemeClr val="bg1"/>
+                </a:solidFill>
+              </a:rPr>
+              <a:t>filters the sample using moving average and outlier rejection then pack two 12bit sample into 3 byte and sends bytes using UART2 to python</a:t>
+            </a:r>
+            <a:endParaRPr lang="zh-CN" altLang="en-US" dirty="0">
+              <a:solidFill>
+                <a:schemeClr val="bg1"/>
+              </a:solidFill>
             </a:endParaRPr>
           </a:p>
         </p:txBody>

</xml_diff>